<commit_message>
add slides day 4
</commit_message>
<xml_diff>
--- a/slides/day1_intro.pptx
+++ b/slides/day1_intro.pptx
@@ -5,7 +5,7 @@
     <p:sldMasterId id="2147483648" r:id="rId1"/>
   </p:sldMasterIdLst>
   <p:notesMasterIdLst>
-    <p:notesMasterId r:id="rId34"/>
+    <p:notesMasterId r:id="rId30"/>
   </p:notesMasterIdLst>
   <p:sldIdLst>
     <p:sldId id="256" r:id="rId2"/>
@@ -28,18 +28,14 @@
     <p:sldId id="298" r:id="rId19"/>
     <p:sldId id="295" r:id="rId20"/>
     <p:sldId id="324" r:id="rId21"/>
-    <p:sldId id="323" r:id="rId22"/>
-    <p:sldId id="299" r:id="rId23"/>
-    <p:sldId id="300" r:id="rId24"/>
-    <p:sldId id="301" r:id="rId25"/>
-    <p:sldId id="327" r:id="rId26"/>
-    <p:sldId id="303" r:id="rId27"/>
-    <p:sldId id="318" r:id="rId28"/>
-    <p:sldId id="278" r:id="rId29"/>
-    <p:sldId id="279" r:id="rId30"/>
-    <p:sldId id="262" r:id="rId31"/>
-    <p:sldId id="281" r:id="rId32"/>
-    <p:sldId id="326" r:id="rId33"/>
+    <p:sldId id="299" r:id="rId22"/>
+    <p:sldId id="300" r:id="rId23"/>
+    <p:sldId id="301" r:id="rId24"/>
+    <p:sldId id="303" r:id="rId25"/>
+    <p:sldId id="318" r:id="rId26"/>
+    <p:sldId id="278" r:id="rId27"/>
+    <p:sldId id="262" r:id="rId28"/>
+    <p:sldId id="281" r:id="rId29"/>
   </p:sldIdLst>
   <p:sldSz cx="12192000" cy="6858000"/>
   <p:notesSz cx="6858000" cy="9144000"/>
@@ -1929,145 +1925,6 @@
         <p:cNvPr id="1" name="">
           <a:extLst>
             <a:ext uri="{FF2B5EF4-FFF2-40B4-BE49-F238E27FC236}">
-              <a16:creationId xmlns:a16="http://schemas.microsoft.com/office/drawing/2014/main" id="{F940C512-90DF-13F9-F943-EA3F3FA6C635}"/>
-            </a:ext>
-          </a:extLst>
-        </p:cNvPr>
-        <p:cNvGrpSpPr/>
-        <p:nvPr/>
-      </p:nvGrpSpPr>
-      <p:grpSpPr>
-        <a:xfrm>
-          <a:off x="0" y="0"/>
-          <a:ext cx="0" cy="0"/>
-          <a:chOff x="0" y="0"/>
-          <a:chExt cx="0" cy="0"/>
-        </a:xfrm>
-      </p:grpSpPr>
-      <p:sp>
-        <p:nvSpPr>
-          <p:cNvPr id="2" name="Slide Image Placeholder 1">
-            <a:extLst>
-              <a:ext uri="{FF2B5EF4-FFF2-40B4-BE49-F238E27FC236}">
-                <a16:creationId xmlns:a16="http://schemas.microsoft.com/office/drawing/2014/main" id="{7789E67D-2EB4-2A19-3AD0-6DF8112EB2EA}"/>
-              </a:ext>
-            </a:extLst>
-          </p:cNvPr>
-          <p:cNvSpPr>
-            <a:spLocks noGrp="1" noRot="1" noChangeAspect="1"/>
-          </p:cNvSpPr>
-          <p:nvPr>
-            <p:ph type="sldImg"/>
-          </p:nvPr>
-        </p:nvSpPr>
-        <p:spPr/>
-      </p:sp>
-      <p:sp>
-        <p:nvSpPr>
-          <p:cNvPr id="3" name="Notes Placeholder 2">
-            <a:extLst>
-              <a:ext uri="{FF2B5EF4-FFF2-40B4-BE49-F238E27FC236}">
-                <a16:creationId xmlns:a16="http://schemas.microsoft.com/office/drawing/2014/main" id="{7501559B-F25B-CC6F-D771-95A82D2766A5}"/>
-              </a:ext>
-            </a:extLst>
-          </p:cNvPr>
-          <p:cNvSpPr>
-            <a:spLocks noGrp="1"/>
-          </p:cNvSpPr>
-          <p:nvPr>
-            <p:ph type="body" idx="1"/>
-          </p:nvPr>
-        </p:nvSpPr>
-        <p:spPr/>
-        <p:txBody>
-          <a:bodyPr/>
-          <a:lstStyle/>
-          <a:p>
-            <a:pPr marL="0" marR="0" lvl="0" indent="0" algn="l" defTabSz="914400" rtl="0" eaLnBrk="1" fontAlgn="auto" latinLnBrk="0" hangingPunct="1">
-              <a:lnSpc>
-                <a:spcPct val="100000"/>
-              </a:lnSpc>
-              <a:spcBef>
-                <a:spcPts val="0"/>
-              </a:spcBef>
-              <a:spcAft>
-                <a:spcPts val="0"/>
-              </a:spcAft>
-              <a:buClrTx/>
-              <a:buSzTx/>
-              <a:buFontTx/>
-              <a:buNone/>
-              <a:tabLst/>
-              <a:defRPr/>
-            </a:pPr>
-            <a:r>
-              <a:rPr lang="en-US" dirty="0">
-                <a:solidFill>
-                  <a:schemeClr val="accent1"/>
-                </a:solidFill>
-              </a:rPr>
-              <a:t>DOM = </a:t>
-            </a:r>
-            <a:r>
-              <a:rPr lang="en-US" dirty="0"/>
-              <a:t>browser’s internal tree representation of a webpage.</a:t>
-            </a:r>
-          </a:p>
-          <a:p>
-            <a:endParaRPr lang="en-US" dirty="0"/>
-          </a:p>
-        </p:txBody>
-      </p:sp>
-      <p:sp>
-        <p:nvSpPr>
-          <p:cNvPr id="4" name="Slide Number Placeholder 3">
-            <a:extLst>
-              <a:ext uri="{FF2B5EF4-FFF2-40B4-BE49-F238E27FC236}">
-                <a16:creationId xmlns:a16="http://schemas.microsoft.com/office/drawing/2014/main" id="{AE852092-4195-ACA7-6B6B-14C3FE874DF6}"/>
-              </a:ext>
-            </a:extLst>
-          </p:cNvPr>
-          <p:cNvSpPr>
-            <a:spLocks noGrp="1"/>
-          </p:cNvSpPr>
-          <p:nvPr>
-            <p:ph type="sldNum" sz="quarter" idx="5"/>
-          </p:nvPr>
-        </p:nvSpPr>
-        <p:spPr/>
-        <p:txBody>
-          <a:bodyPr/>
-          <a:lstStyle/>
-          <a:p>
-            <a:fld id="{FF78EFD2-C9A0-A146-8CE9-0A2B7CC7B867}" type="slidenum">
-              <a:rPr lang="en-US" smtClean="0"/>
-              <a:t>21</a:t>
-            </a:fld>
-            <a:endParaRPr lang="en-US"/>
-          </a:p>
-        </p:txBody>
-      </p:sp>
-    </p:spTree>
-    <p:extLst>
-      <p:ext uri="{BB962C8B-B14F-4D97-AF65-F5344CB8AC3E}">
-        <p14:creationId xmlns:p14="http://schemas.microsoft.com/office/powerpoint/2010/main" val="1239298422"/>
-      </p:ext>
-    </p:extLst>
-  </p:cSld>
-  <p:clrMapOvr>
-    <a:masterClrMapping/>
-  </p:clrMapOvr>
-</p:notes>
-</file>
-
-<file path=ppt/notesSlides/notesSlide22.xml><?xml version="1.0" encoding="utf-8"?>
-<p:notes xmlns:a="http://schemas.openxmlformats.org/drawingml/2006/main" xmlns:r="http://schemas.openxmlformats.org/officeDocument/2006/relationships" xmlns:p="http://schemas.openxmlformats.org/presentationml/2006/main">
-  <p:cSld>
-    <p:spTree>
-      <p:nvGrpSpPr>
-        <p:cNvPr id="1" name="">
-          <a:extLst>
-            <a:ext uri="{FF2B5EF4-FFF2-40B4-BE49-F238E27FC236}">
               <a16:creationId xmlns:a16="http://schemas.microsoft.com/office/drawing/2014/main" id="{83AA515B-4A2F-0A16-3F98-99D71AB7122D}"/>
             </a:ext>
           </a:extLst>
@@ -2149,7 +2006,7 @@
           <a:p>
             <a:fld id="{FF78EFD2-C9A0-A146-8CE9-0A2B7CC7B867}" type="slidenum">
               <a:rPr lang="en-US" smtClean="0"/>
-              <a:t>22</a:t>
+              <a:t>21</a:t>
             </a:fld>
             <a:endParaRPr lang="en-US"/>
           </a:p>
@@ -2168,7 +2025,7 @@
 </p:notes>
 </file>
 
-<file path=ppt/notesSlides/notesSlide23.xml><?xml version="1.0" encoding="utf-8"?>
+<file path=ppt/notesSlides/notesSlide22.xml><?xml version="1.0" encoding="utf-8"?>
 <p:notes xmlns:a="http://schemas.openxmlformats.org/drawingml/2006/main" xmlns:r="http://schemas.openxmlformats.org/officeDocument/2006/relationships" xmlns:p="http://schemas.openxmlformats.org/presentationml/2006/main">
   <p:cSld>
     <p:spTree>
@@ -2257,7 +2114,7 @@
           <a:p>
             <a:fld id="{FF78EFD2-C9A0-A146-8CE9-0A2B7CC7B867}" type="slidenum">
               <a:rPr lang="en-US" smtClean="0"/>
-              <a:t>23</a:t>
+              <a:t>22</a:t>
             </a:fld>
             <a:endParaRPr lang="en-US"/>
           </a:p>
@@ -2276,7 +2133,7 @@
 </p:notes>
 </file>
 
-<file path=ppt/notesSlides/notesSlide24.xml><?xml version="1.0" encoding="utf-8"?>
+<file path=ppt/notesSlides/notesSlide23.xml><?xml version="1.0" encoding="utf-8"?>
 <p:notes xmlns:a="http://schemas.openxmlformats.org/drawingml/2006/main" xmlns:r="http://schemas.openxmlformats.org/officeDocument/2006/relationships" xmlns:p="http://schemas.openxmlformats.org/presentationml/2006/main">
   <p:cSld>
     <p:spTree>
@@ -2365,7 +2222,7 @@
           <a:p>
             <a:fld id="{FF78EFD2-C9A0-A146-8CE9-0A2B7CC7B867}" type="slidenum">
               <a:rPr lang="en-US" smtClean="0"/>
-              <a:t>24</a:t>
+              <a:t>23</a:t>
             </a:fld>
             <a:endParaRPr lang="en-US"/>
           </a:p>
@@ -2384,115 +2241,7 @@
 </p:notes>
 </file>
 
-<file path=ppt/notesSlides/notesSlide25.xml><?xml version="1.0" encoding="utf-8"?>
-<p:notes xmlns:a="http://schemas.openxmlformats.org/drawingml/2006/main" xmlns:r="http://schemas.openxmlformats.org/officeDocument/2006/relationships" xmlns:p="http://schemas.openxmlformats.org/presentationml/2006/main">
-  <p:cSld>
-    <p:spTree>
-      <p:nvGrpSpPr>
-        <p:cNvPr id="1" name="">
-          <a:extLst>
-            <a:ext uri="{FF2B5EF4-FFF2-40B4-BE49-F238E27FC236}">
-              <a16:creationId xmlns:a16="http://schemas.microsoft.com/office/drawing/2014/main" id="{8D9CA44E-4185-3E50-856F-6F6D0123BA90}"/>
-            </a:ext>
-          </a:extLst>
-        </p:cNvPr>
-        <p:cNvGrpSpPr/>
-        <p:nvPr/>
-      </p:nvGrpSpPr>
-      <p:grpSpPr>
-        <a:xfrm>
-          <a:off x="0" y="0"/>
-          <a:ext cx="0" cy="0"/>
-          <a:chOff x="0" y="0"/>
-          <a:chExt cx="0" cy="0"/>
-        </a:xfrm>
-      </p:grpSpPr>
-      <p:sp>
-        <p:nvSpPr>
-          <p:cNvPr id="2" name="Slide Image Placeholder 1">
-            <a:extLst>
-              <a:ext uri="{FF2B5EF4-FFF2-40B4-BE49-F238E27FC236}">
-                <a16:creationId xmlns:a16="http://schemas.microsoft.com/office/drawing/2014/main" id="{EE732686-ECA5-351F-17DD-48ECF6A7C804}"/>
-              </a:ext>
-            </a:extLst>
-          </p:cNvPr>
-          <p:cNvSpPr>
-            <a:spLocks noGrp="1" noRot="1" noChangeAspect="1"/>
-          </p:cNvSpPr>
-          <p:nvPr>
-            <p:ph type="sldImg"/>
-          </p:nvPr>
-        </p:nvSpPr>
-        <p:spPr/>
-      </p:sp>
-      <p:sp>
-        <p:nvSpPr>
-          <p:cNvPr id="3" name="Notes Placeholder 2">
-            <a:extLst>
-              <a:ext uri="{FF2B5EF4-FFF2-40B4-BE49-F238E27FC236}">
-                <a16:creationId xmlns:a16="http://schemas.microsoft.com/office/drawing/2014/main" id="{27642A89-2895-9EB1-B77E-F996DD3017F2}"/>
-              </a:ext>
-            </a:extLst>
-          </p:cNvPr>
-          <p:cNvSpPr>
-            <a:spLocks noGrp="1"/>
-          </p:cNvSpPr>
-          <p:nvPr>
-            <p:ph type="body" idx="1"/>
-          </p:nvPr>
-        </p:nvSpPr>
-        <p:spPr/>
-        <p:txBody>
-          <a:bodyPr/>
-          <a:lstStyle/>
-          <a:p>
-            <a:endParaRPr lang="en-US" dirty="0"/>
-          </a:p>
-        </p:txBody>
-      </p:sp>
-      <p:sp>
-        <p:nvSpPr>
-          <p:cNvPr id="4" name="Slide Number Placeholder 3">
-            <a:extLst>
-              <a:ext uri="{FF2B5EF4-FFF2-40B4-BE49-F238E27FC236}">
-                <a16:creationId xmlns:a16="http://schemas.microsoft.com/office/drawing/2014/main" id="{38DB97B3-6B14-01C8-2D6C-40715B059FB2}"/>
-              </a:ext>
-            </a:extLst>
-          </p:cNvPr>
-          <p:cNvSpPr>
-            <a:spLocks noGrp="1"/>
-          </p:cNvSpPr>
-          <p:nvPr>
-            <p:ph type="sldNum" sz="quarter" idx="5"/>
-          </p:nvPr>
-        </p:nvSpPr>
-        <p:spPr/>
-        <p:txBody>
-          <a:bodyPr/>
-          <a:lstStyle/>
-          <a:p>
-            <a:fld id="{FF78EFD2-C9A0-A146-8CE9-0A2B7CC7B867}" type="slidenum">
-              <a:rPr lang="en-US" smtClean="0"/>
-              <a:t>25</a:t>
-            </a:fld>
-            <a:endParaRPr lang="en-US"/>
-          </a:p>
-        </p:txBody>
-      </p:sp>
-    </p:spTree>
-    <p:extLst>
-      <p:ext uri="{BB962C8B-B14F-4D97-AF65-F5344CB8AC3E}">
-        <p14:creationId xmlns:p14="http://schemas.microsoft.com/office/powerpoint/2010/main" val="3638055156"/>
-      </p:ext>
-    </p:extLst>
-  </p:cSld>
-  <p:clrMapOvr>
-    <a:masterClrMapping/>
-  </p:clrMapOvr>
-</p:notes>
-</file>
-
-<file path=ppt/notesSlides/notesSlide26.xml><?xml version="1.0" encoding="utf-8"?>
+<file path=ppt/notesSlides/notesSlide24.xml><?xml version="1.0" encoding="utf-8"?>
 <p:notes xmlns:a="http://schemas.openxmlformats.org/drawingml/2006/main" xmlns:r="http://schemas.openxmlformats.org/officeDocument/2006/relationships" xmlns:p="http://schemas.openxmlformats.org/presentationml/2006/main">
   <p:cSld>
     <p:spTree>
@@ -2581,7 +2330,7 @@
           <a:p>
             <a:fld id="{FF78EFD2-C9A0-A146-8CE9-0A2B7CC7B867}" type="slidenum">
               <a:rPr lang="en-US" smtClean="0"/>
-              <a:t>26</a:t>
+              <a:t>24</a:t>
             </a:fld>
             <a:endParaRPr lang="en-US"/>
           </a:p>
@@ -2600,7 +2349,7 @@
 </p:notes>
 </file>
 
-<file path=ppt/notesSlides/notesSlide27.xml><?xml version="1.0" encoding="utf-8"?>
+<file path=ppt/notesSlides/notesSlide25.xml><?xml version="1.0" encoding="utf-8"?>
 <p:notes xmlns:a="http://schemas.openxmlformats.org/drawingml/2006/main" xmlns:r="http://schemas.openxmlformats.org/officeDocument/2006/relationships" xmlns:p="http://schemas.openxmlformats.org/presentationml/2006/main">
   <p:cSld>
     <p:spTree>
@@ -2689,7 +2438,7 @@
           <a:p>
             <a:fld id="{FF78EFD2-C9A0-A146-8CE9-0A2B7CC7B867}" type="slidenum">
               <a:rPr lang="en-US" smtClean="0"/>
-              <a:t>27</a:t>
+              <a:t>25</a:t>
             </a:fld>
             <a:endParaRPr lang="en-US"/>
           </a:p>
@@ -2708,7 +2457,7 @@
 </p:notes>
 </file>
 
-<file path=ppt/notesSlides/notesSlide28.xml><?xml version="1.0" encoding="utf-8"?>
+<file path=ppt/notesSlides/notesSlide26.xml><?xml version="1.0" encoding="utf-8"?>
 <p:notes xmlns:a="http://schemas.openxmlformats.org/drawingml/2006/main" xmlns:r="http://schemas.openxmlformats.org/officeDocument/2006/relationships" xmlns:p="http://schemas.openxmlformats.org/presentationml/2006/main">
   <p:cSld>
     <p:spTree>
@@ -2820,7 +2569,7 @@
           <a:p>
             <a:fld id="{FF78EFD2-C9A0-A146-8CE9-0A2B7CC7B867}" type="slidenum">
               <a:rPr lang="en-US" smtClean="0"/>
-              <a:t>28</a:t>
+              <a:t>26</a:t>
             </a:fld>
             <a:endParaRPr lang="en-US"/>
           </a:p>
@@ -2839,7 +2588,7 @@
 </p:notes>
 </file>
 
-<file path=ppt/notesSlides/notesSlide29.xml><?xml version="1.0" encoding="utf-8"?>
+<file path=ppt/notesSlides/notesSlide27.xml><?xml version="1.0" encoding="utf-8"?>
 <p:notes xmlns:a="http://schemas.openxmlformats.org/drawingml/2006/main" xmlns:r="http://schemas.openxmlformats.org/officeDocument/2006/relationships" xmlns:p="http://schemas.openxmlformats.org/presentationml/2006/main">
   <p:cSld>
     <p:spTree>
@@ -2847,7 +2596,7 @@
         <p:cNvPr id="1" name="">
           <a:extLst>
             <a:ext uri="{FF2B5EF4-FFF2-40B4-BE49-F238E27FC236}">
-              <a16:creationId xmlns:a16="http://schemas.microsoft.com/office/drawing/2014/main" id="{0622ED16-FBE9-20D7-BB46-76C1843FD729}"/>
+              <a16:creationId xmlns:a16="http://schemas.microsoft.com/office/drawing/2014/main" id="{14E9B45F-1925-C993-4D16-2EDD49557B8A}"/>
             </a:ext>
           </a:extLst>
         </p:cNvPr>
@@ -2867,7 +2616,7 @@
           <p:cNvPr id="2" name="Slide Image Placeholder 1">
             <a:extLst>
               <a:ext uri="{FF2B5EF4-FFF2-40B4-BE49-F238E27FC236}">
-                <a16:creationId xmlns:a16="http://schemas.microsoft.com/office/drawing/2014/main" id="{281ECAF1-1509-7F11-DDFE-83E267EE6CC6}"/>
+                <a16:creationId xmlns:a16="http://schemas.microsoft.com/office/drawing/2014/main" id="{C49CA2D9-9456-F7EC-8DC1-C8F665EFD72C}"/>
               </a:ext>
             </a:extLst>
           </p:cNvPr>
@@ -2885,7 +2634,7 @@
           <p:cNvPr id="3" name="Notes Placeholder 2">
             <a:extLst>
               <a:ext uri="{FF2B5EF4-FFF2-40B4-BE49-F238E27FC236}">
-                <a16:creationId xmlns:a16="http://schemas.microsoft.com/office/drawing/2014/main" id="{3E41390C-F971-DAE8-8544-B46F6020D865}"/>
+                <a16:creationId xmlns:a16="http://schemas.microsoft.com/office/drawing/2014/main" id="{0C9EACDC-32C1-C9B0-6E22-4ECA6772DB85}"/>
               </a:ext>
             </a:extLst>
           </p:cNvPr>
@@ -2901,180 +2650,6 @@
           <a:bodyPr/>
           <a:lstStyle/>
           <a:p>
-            <a:pPr rtl="0" fontAlgn="base"/>
-            <a:r>
-              <a:rPr lang="en-US" sz="1200" b="0" i="0" u="none" strike="noStrike" kern="1200" dirty="0">
-                <a:solidFill>
-                  <a:schemeClr val="tx1"/>
-                </a:solidFill>
-                <a:effectLst/>
-                <a:latin typeface="+mn-lt"/>
-                <a:ea typeface="+mn-ea"/>
-                <a:cs typeface="+mn-cs"/>
-              </a:rPr>
-              <a:t>Images taken from: https://</a:t>
-            </a:r>
-            <a:r>
-              <a:rPr lang="en-US" sz="1200" b="0" i="0" u="none" strike="noStrike" kern="1200" dirty="0" err="1">
-                <a:solidFill>
-                  <a:schemeClr val="tx1"/>
-                </a:solidFill>
-                <a:effectLst/>
-                <a:latin typeface="+mn-lt"/>
-                <a:ea typeface="+mn-ea"/>
-                <a:cs typeface="+mn-cs"/>
-              </a:rPr>
-              <a:t>www.geeksforgeeks.org</a:t>
-            </a:r>
-            <a:r>
-              <a:rPr lang="en-US" sz="1200" b="0" i="0" u="none" strike="noStrike" kern="1200" dirty="0">
-                <a:solidFill>
-                  <a:schemeClr val="tx1"/>
-                </a:solidFill>
-                <a:effectLst/>
-                <a:latin typeface="+mn-lt"/>
-                <a:ea typeface="+mn-ea"/>
-                <a:cs typeface="+mn-cs"/>
-              </a:rPr>
-              <a:t>/software-testing/what-is-an-</a:t>
-            </a:r>
-            <a:r>
-              <a:rPr lang="en-US" sz="1200" b="0" i="0" u="none" strike="noStrike" kern="1200" dirty="0" err="1">
-                <a:solidFill>
-                  <a:schemeClr val="tx1"/>
-                </a:solidFill>
-                <a:effectLst/>
-                <a:latin typeface="+mn-lt"/>
-                <a:ea typeface="+mn-ea"/>
-                <a:cs typeface="+mn-cs"/>
-              </a:rPr>
-              <a:t>api</a:t>
-            </a:r>
-            <a:r>
-              <a:rPr lang="en-US" sz="1200" b="0" i="0" u="none" strike="noStrike" kern="1200" dirty="0">
-                <a:solidFill>
-                  <a:schemeClr val="tx1"/>
-                </a:solidFill>
-                <a:effectLst/>
-                <a:latin typeface="+mn-lt"/>
-                <a:ea typeface="+mn-ea"/>
-                <a:cs typeface="+mn-cs"/>
-              </a:rPr>
-              <a:t>/</a:t>
-            </a:r>
-          </a:p>
-          <a:p>
-            <a:pPr rtl="0" fontAlgn="base"/>
-            <a:endParaRPr lang="en-US" sz="1200" b="0" i="0" u="none" strike="noStrike" kern="1200" dirty="0">
-              <a:solidFill>
-                <a:schemeClr val="tx1"/>
-              </a:solidFill>
-              <a:effectLst/>
-              <a:latin typeface="+mn-lt"/>
-              <a:ea typeface="+mn-ea"/>
-              <a:cs typeface="+mn-cs"/>
-            </a:endParaRPr>
-          </a:p>
-          <a:p>
-            <a:pPr rtl="0" fontAlgn="base"/>
-            <a:endParaRPr lang="en-US" sz="1200" b="0" i="0" u="none" strike="noStrike" kern="1200" dirty="0">
-              <a:solidFill>
-                <a:schemeClr val="tx1"/>
-              </a:solidFill>
-              <a:effectLst/>
-              <a:latin typeface="+mn-lt"/>
-              <a:ea typeface="+mn-ea"/>
-              <a:cs typeface="+mn-cs"/>
-            </a:endParaRPr>
-          </a:p>
-          <a:p>
-            <a:pPr rtl="0" fontAlgn="base"/>
-            <a:endParaRPr lang="en-US" sz="1200" b="0" i="0" u="none" strike="noStrike" kern="1200" dirty="0">
-              <a:solidFill>
-                <a:schemeClr val="tx1"/>
-              </a:solidFill>
-              <a:effectLst/>
-              <a:latin typeface="+mn-lt"/>
-              <a:ea typeface="+mn-ea"/>
-              <a:cs typeface="+mn-cs"/>
-            </a:endParaRPr>
-          </a:p>
-          <a:p>
-            <a:pPr rtl="0" fontAlgn="base"/>
-            <a:r>
-              <a:rPr lang="en-US" sz="1200" b="0" i="0" u="none" strike="noStrike" kern="1200" dirty="0">
-                <a:solidFill>
-                  <a:schemeClr val="tx1"/>
-                </a:solidFill>
-                <a:effectLst/>
-                <a:latin typeface="+mn-lt"/>
-                <a:ea typeface="+mn-ea"/>
-                <a:cs typeface="+mn-cs"/>
-              </a:rPr>
-              <a:t>Imagine you’re at a restaurant:</a:t>
-            </a:r>
-          </a:p>
-          <a:p>
-            <a:pPr fontAlgn="base"/>
-            <a:r>
-              <a:rPr lang="en-US" sz="1200" b="0" i="0" u="none" strike="noStrike" kern="1200" dirty="0">
-                <a:solidFill>
-                  <a:schemeClr val="tx1"/>
-                </a:solidFill>
-                <a:effectLst/>
-                <a:latin typeface="+mn-lt"/>
-                <a:ea typeface="+mn-ea"/>
-                <a:cs typeface="+mn-cs"/>
-              </a:rPr>
-              <a:t>You (the client) place an order with the waiter.</a:t>
-            </a:r>
-          </a:p>
-          <a:p>
-            <a:pPr fontAlgn="base"/>
-            <a:r>
-              <a:rPr lang="en-US" sz="1200" b="0" i="0" u="none" strike="noStrike" kern="1200" dirty="0">
-                <a:solidFill>
-                  <a:schemeClr val="tx1"/>
-                </a:solidFill>
-                <a:effectLst/>
-                <a:latin typeface="+mn-lt"/>
-                <a:ea typeface="+mn-ea"/>
-                <a:cs typeface="+mn-cs"/>
-              </a:rPr>
-              <a:t>The waiter (the API) conveys your request to the chef (the server).</a:t>
-            </a:r>
-          </a:p>
-          <a:p>
-            <a:pPr fontAlgn="base"/>
-            <a:r>
-              <a:rPr lang="en-US" sz="1200" b="0" i="0" u="none" strike="noStrike" kern="1200" dirty="0">
-                <a:solidFill>
-                  <a:schemeClr val="tx1"/>
-                </a:solidFill>
-                <a:effectLst/>
-                <a:latin typeface="+mn-lt"/>
-                <a:ea typeface="+mn-ea"/>
-                <a:cs typeface="+mn-cs"/>
-              </a:rPr>
-              <a:t>The chef prepares the food (processes the request) and gives it to the waiter.</a:t>
-            </a:r>
-          </a:p>
-          <a:p>
-            <a:pPr fontAlgn="base"/>
-            <a:r>
-              <a:rPr lang="en-US" sz="1200" b="0" i="0" u="none" strike="noStrike" kern="1200" dirty="0">
-                <a:solidFill>
-                  <a:schemeClr val="tx1"/>
-                </a:solidFill>
-                <a:effectLst/>
-                <a:latin typeface="+mn-lt"/>
-                <a:ea typeface="+mn-ea"/>
-                <a:cs typeface="+mn-cs"/>
-              </a:rPr>
-              <a:t>The waiter delivers it back to your table (response).</a:t>
-            </a:r>
-          </a:p>
-          <a:p>
             <a:endParaRPr lang="en-US" dirty="0"/>
           </a:p>
         </p:txBody>
@@ -3084,7 +2659,7 @@
           <p:cNvPr id="4" name="Slide Number Placeholder 3">
             <a:extLst>
               <a:ext uri="{FF2B5EF4-FFF2-40B4-BE49-F238E27FC236}">
-                <a16:creationId xmlns:a16="http://schemas.microsoft.com/office/drawing/2014/main" id="{D17C6DFD-53E9-3741-10AE-DFFB7B896666}"/>
+                <a16:creationId xmlns:a16="http://schemas.microsoft.com/office/drawing/2014/main" id="{B076A8F6-FBFE-C7A4-1FE6-3C975A358E90}"/>
               </a:ext>
             </a:extLst>
           </p:cNvPr>
@@ -3102,7 +2677,7 @@
           <a:p>
             <a:fld id="{FF78EFD2-C9A0-A146-8CE9-0A2B7CC7B867}" type="slidenum">
               <a:rPr lang="en-US" smtClean="0"/>
-              <a:t>29</a:t>
+              <a:t>27</a:t>
             </a:fld>
             <a:endParaRPr lang="en-US"/>
           </a:p>
@@ -3111,7 +2686,115 @@
     </p:spTree>
     <p:extLst>
       <p:ext uri="{BB962C8B-B14F-4D97-AF65-F5344CB8AC3E}">
-        <p14:creationId xmlns:p14="http://schemas.microsoft.com/office/powerpoint/2010/main" val="3341870626"/>
+        <p14:creationId xmlns:p14="http://schemas.microsoft.com/office/powerpoint/2010/main" val="1888415515"/>
+      </p:ext>
+    </p:extLst>
+  </p:cSld>
+  <p:clrMapOvr>
+    <a:masterClrMapping/>
+  </p:clrMapOvr>
+</p:notes>
+</file>
+
+<file path=ppt/notesSlides/notesSlide28.xml><?xml version="1.0" encoding="utf-8"?>
+<p:notes xmlns:a="http://schemas.openxmlformats.org/drawingml/2006/main" xmlns:r="http://schemas.openxmlformats.org/officeDocument/2006/relationships" xmlns:p="http://schemas.openxmlformats.org/presentationml/2006/main">
+  <p:cSld>
+    <p:spTree>
+      <p:nvGrpSpPr>
+        <p:cNvPr id="1" name="">
+          <a:extLst>
+            <a:ext uri="{FF2B5EF4-FFF2-40B4-BE49-F238E27FC236}">
+              <a16:creationId xmlns:a16="http://schemas.microsoft.com/office/drawing/2014/main" id="{8276AB12-E4BE-2895-5942-8EB3594FC13C}"/>
+            </a:ext>
+          </a:extLst>
+        </p:cNvPr>
+        <p:cNvGrpSpPr/>
+        <p:nvPr/>
+      </p:nvGrpSpPr>
+      <p:grpSpPr>
+        <a:xfrm>
+          <a:off x="0" y="0"/>
+          <a:ext cx="0" cy="0"/>
+          <a:chOff x="0" y="0"/>
+          <a:chExt cx="0" cy="0"/>
+        </a:xfrm>
+      </p:grpSpPr>
+      <p:sp>
+        <p:nvSpPr>
+          <p:cNvPr id="2" name="Slide Image Placeholder 1">
+            <a:extLst>
+              <a:ext uri="{FF2B5EF4-FFF2-40B4-BE49-F238E27FC236}">
+                <a16:creationId xmlns:a16="http://schemas.microsoft.com/office/drawing/2014/main" id="{6E17AFE7-48E9-FF99-5E65-E91DF6095D03}"/>
+              </a:ext>
+            </a:extLst>
+          </p:cNvPr>
+          <p:cNvSpPr>
+            <a:spLocks noGrp="1" noRot="1" noChangeAspect="1"/>
+          </p:cNvSpPr>
+          <p:nvPr>
+            <p:ph type="sldImg"/>
+          </p:nvPr>
+        </p:nvSpPr>
+        <p:spPr/>
+      </p:sp>
+      <p:sp>
+        <p:nvSpPr>
+          <p:cNvPr id="3" name="Notes Placeholder 2">
+            <a:extLst>
+              <a:ext uri="{FF2B5EF4-FFF2-40B4-BE49-F238E27FC236}">
+                <a16:creationId xmlns:a16="http://schemas.microsoft.com/office/drawing/2014/main" id="{BBFE2B31-C66D-6B10-48B6-0240355441A5}"/>
+              </a:ext>
+            </a:extLst>
+          </p:cNvPr>
+          <p:cNvSpPr>
+            <a:spLocks noGrp="1"/>
+          </p:cNvSpPr>
+          <p:nvPr>
+            <p:ph type="body" idx="1"/>
+          </p:nvPr>
+        </p:nvSpPr>
+        <p:spPr/>
+        <p:txBody>
+          <a:bodyPr/>
+          <a:lstStyle/>
+          <a:p>
+            <a:endParaRPr lang="en-US" dirty="0"/>
+          </a:p>
+        </p:txBody>
+      </p:sp>
+      <p:sp>
+        <p:nvSpPr>
+          <p:cNvPr id="4" name="Slide Number Placeholder 3">
+            <a:extLst>
+              <a:ext uri="{FF2B5EF4-FFF2-40B4-BE49-F238E27FC236}">
+                <a16:creationId xmlns:a16="http://schemas.microsoft.com/office/drawing/2014/main" id="{3D606F75-A8C9-FA91-51FD-42BB66D7058F}"/>
+              </a:ext>
+            </a:extLst>
+          </p:cNvPr>
+          <p:cNvSpPr>
+            <a:spLocks noGrp="1"/>
+          </p:cNvSpPr>
+          <p:nvPr>
+            <p:ph type="sldNum" sz="quarter" idx="5"/>
+          </p:nvPr>
+        </p:nvSpPr>
+        <p:spPr/>
+        <p:txBody>
+          <a:bodyPr/>
+          <a:lstStyle/>
+          <a:p>
+            <a:fld id="{FF78EFD2-C9A0-A146-8CE9-0A2B7CC7B867}" type="slidenum">
+              <a:rPr lang="en-US" smtClean="0"/>
+              <a:t>28</a:t>
+            </a:fld>
+            <a:endParaRPr lang="en-US"/>
+          </a:p>
+        </p:txBody>
+      </p:sp>
+    </p:spTree>
+    <p:extLst>
+      <p:ext uri="{BB962C8B-B14F-4D97-AF65-F5344CB8AC3E}">
+        <p14:creationId xmlns:p14="http://schemas.microsoft.com/office/powerpoint/2010/main" val="1675293660"/>
       </p:ext>
     </p:extLst>
   </p:cSld>
@@ -3220,375 +2903,6 @@
     <p:extLst>
       <p:ext uri="{BB962C8B-B14F-4D97-AF65-F5344CB8AC3E}">
         <p14:creationId xmlns:p14="http://schemas.microsoft.com/office/powerpoint/2010/main" val="854750004"/>
-      </p:ext>
-    </p:extLst>
-  </p:cSld>
-  <p:clrMapOvr>
-    <a:masterClrMapping/>
-  </p:clrMapOvr>
-</p:notes>
-</file>
-
-<file path=ppt/notesSlides/notesSlide30.xml><?xml version="1.0" encoding="utf-8"?>
-<p:notes xmlns:a="http://schemas.openxmlformats.org/drawingml/2006/main" xmlns:r="http://schemas.openxmlformats.org/officeDocument/2006/relationships" xmlns:p="http://schemas.openxmlformats.org/presentationml/2006/main">
-  <p:cSld>
-    <p:spTree>
-      <p:nvGrpSpPr>
-        <p:cNvPr id="1" name="">
-          <a:extLst>
-            <a:ext uri="{FF2B5EF4-FFF2-40B4-BE49-F238E27FC236}">
-              <a16:creationId xmlns:a16="http://schemas.microsoft.com/office/drawing/2014/main" id="{14E9B45F-1925-C993-4D16-2EDD49557B8A}"/>
-            </a:ext>
-          </a:extLst>
-        </p:cNvPr>
-        <p:cNvGrpSpPr/>
-        <p:nvPr/>
-      </p:nvGrpSpPr>
-      <p:grpSpPr>
-        <a:xfrm>
-          <a:off x="0" y="0"/>
-          <a:ext cx="0" cy="0"/>
-          <a:chOff x="0" y="0"/>
-          <a:chExt cx="0" cy="0"/>
-        </a:xfrm>
-      </p:grpSpPr>
-      <p:sp>
-        <p:nvSpPr>
-          <p:cNvPr id="2" name="Slide Image Placeholder 1">
-            <a:extLst>
-              <a:ext uri="{FF2B5EF4-FFF2-40B4-BE49-F238E27FC236}">
-                <a16:creationId xmlns:a16="http://schemas.microsoft.com/office/drawing/2014/main" id="{C49CA2D9-9456-F7EC-8DC1-C8F665EFD72C}"/>
-              </a:ext>
-            </a:extLst>
-          </p:cNvPr>
-          <p:cNvSpPr>
-            <a:spLocks noGrp="1" noRot="1" noChangeAspect="1"/>
-          </p:cNvSpPr>
-          <p:nvPr>
-            <p:ph type="sldImg"/>
-          </p:nvPr>
-        </p:nvSpPr>
-        <p:spPr/>
-      </p:sp>
-      <p:sp>
-        <p:nvSpPr>
-          <p:cNvPr id="3" name="Notes Placeholder 2">
-            <a:extLst>
-              <a:ext uri="{FF2B5EF4-FFF2-40B4-BE49-F238E27FC236}">
-                <a16:creationId xmlns:a16="http://schemas.microsoft.com/office/drawing/2014/main" id="{0C9EACDC-32C1-C9B0-6E22-4ECA6772DB85}"/>
-              </a:ext>
-            </a:extLst>
-          </p:cNvPr>
-          <p:cNvSpPr>
-            <a:spLocks noGrp="1"/>
-          </p:cNvSpPr>
-          <p:nvPr>
-            <p:ph type="body" idx="1"/>
-          </p:nvPr>
-        </p:nvSpPr>
-        <p:spPr/>
-        <p:txBody>
-          <a:bodyPr/>
-          <a:lstStyle/>
-          <a:p>
-            <a:endParaRPr lang="en-US" dirty="0"/>
-          </a:p>
-        </p:txBody>
-      </p:sp>
-      <p:sp>
-        <p:nvSpPr>
-          <p:cNvPr id="4" name="Slide Number Placeholder 3">
-            <a:extLst>
-              <a:ext uri="{FF2B5EF4-FFF2-40B4-BE49-F238E27FC236}">
-                <a16:creationId xmlns:a16="http://schemas.microsoft.com/office/drawing/2014/main" id="{B076A8F6-FBFE-C7A4-1FE6-3C975A358E90}"/>
-              </a:ext>
-            </a:extLst>
-          </p:cNvPr>
-          <p:cNvSpPr>
-            <a:spLocks noGrp="1"/>
-          </p:cNvSpPr>
-          <p:nvPr>
-            <p:ph type="sldNum" sz="quarter" idx="5"/>
-          </p:nvPr>
-        </p:nvSpPr>
-        <p:spPr/>
-        <p:txBody>
-          <a:bodyPr/>
-          <a:lstStyle/>
-          <a:p>
-            <a:fld id="{FF78EFD2-C9A0-A146-8CE9-0A2B7CC7B867}" type="slidenum">
-              <a:rPr lang="en-US" smtClean="0"/>
-              <a:t>30</a:t>
-            </a:fld>
-            <a:endParaRPr lang="en-US"/>
-          </a:p>
-        </p:txBody>
-      </p:sp>
-    </p:spTree>
-    <p:extLst>
-      <p:ext uri="{BB962C8B-B14F-4D97-AF65-F5344CB8AC3E}">
-        <p14:creationId xmlns:p14="http://schemas.microsoft.com/office/powerpoint/2010/main" val="1888415515"/>
-      </p:ext>
-    </p:extLst>
-  </p:cSld>
-  <p:clrMapOvr>
-    <a:masterClrMapping/>
-  </p:clrMapOvr>
-</p:notes>
-</file>
-
-<file path=ppt/notesSlides/notesSlide31.xml><?xml version="1.0" encoding="utf-8"?>
-<p:notes xmlns:a="http://schemas.openxmlformats.org/drawingml/2006/main" xmlns:r="http://schemas.openxmlformats.org/officeDocument/2006/relationships" xmlns:p="http://schemas.openxmlformats.org/presentationml/2006/main">
-  <p:cSld>
-    <p:spTree>
-      <p:nvGrpSpPr>
-        <p:cNvPr id="1" name="">
-          <a:extLst>
-            <a:ext uri="{FF2B5EF4-FFF2-40B4-BE49-F238E27FC236}">
-              <a16:creationId xmlns:a16="http://schemas.microsoft.com/office/drawing/2014/main" id="{8276AB12-E4BE-2895-5942-8EB3594FC13C}"/>
-            </a:ext>
-          </a:extLst>
-        </p:cNvPr>
-        <p:cNvGrpSpPr/>
-        <p:nvPr/>
-      </p:nvGrpSpPr>
-      <p:grpSpPr>
-        <a:xfrm>
-          <a:off x="0" y="0"/>
-          <a:ext cx="0" cy="0"/>
-          <a:chOff x="0" y="0"/>
-          <a:chExt cx="0" cy="0"/>
-        </a:xfrm>
-      </p:grpSpPr>
-      <p:sp>
-        <p:nvSpPr>
-          <p:cNvPr id="2" name="Slide Image Placeholder 1">
-            <a:extLst>
-              <a:ext uri="{FF2B5EF4-FFF2-40B4-BE49-F238E27FC236}">
-                <a16:creationId xmlns:a16="http://schemas.microsoft.com/office/drawing/2014/main" id="{6E17AFE7-48E9-FF99-5E65-E91DF6095D03}"/>
-              </a:ext>
-            </a:extLst>
-          </p:cNvPr>
-          <p:cNvSpPr>
-            <a:spLocks noGrp="1" noRot="1" noChangeAspect="1"/>
-          </p:cNvSpPr>
-          <p:nvPr>
-            <p:ph type="sldImg"/>
-          </p:nvPr>
-        </p:nvSpPr>
-        <p:spPr/>
-      </p:sp>
-      <p:sp>
-        <p:nvSpPr>
-          <p:cNvPr id="3" name="Notes Placeholder 2">
-            <a:extLst>
-              <a:ext uri="{FF2B5EF4-FFF2-40B4-BE49-F238E27FC236}">
-                <a16:creationId xmlns:a16="http://schemas.microsoft.com/office/drawing/2014/main" id="{BBFE2B31-C66D-6B10-48B6-0240355441A5}"/>
-              </a:ext>
-            </a:extLst>
-          </p:cNvPr>
-          <p:cNvSpPr>
-            <a:spLocks noGrp="1"/>
-          </p:cNvSpPr>
-          <p:nvPr>
-            <p:ph type="body" idx="1"/>
-          </p:nvPr>
-        </p:nvSpPr>
-        <p:spPr/>
-        <p:txBody>
-          <a:bodyPr/>
-          <a:lstStyle/>
-          <a:p>
-            <a:endParaRPr lang="en-US" dirty="0"/>
-          </a:p>
-        </p:txBody>
-      </p:sp>
-      <p:sp>
-        <p:nvSpPr>
-          <p:cNvPr id="4" name="Slide Number Placeholder 3">
-            <a:extLst>
-              <a:ext uri="{FF2B5EF4-FFF2-40B4-BE49-F238E27FC236}">
-                <a16:creationId xmlns:a16="http://schemas.microsoft.com/office/drawing/2014/main" id="{3D606F75-A8C9-FA91-51FD-42BB66D7058F}"/>
-              </a:ext>
-            </a:extLst>
-          </p:cNvPr>
-          <p:cNvSpPr>
-            <a:spLocks noGrp="1"/>
-          </p:cNvSpPr>
-          <p:nvPr>
-            <p:ph type="sldNum" sz="quarter" idx="5"/>
-          </p:nvPr>
-        </p:nvSpPr>
-        <p:spPr/>
-        <p:txBody>
-          <a:bodyPr/>
-          <a:lstStyle/>
-          <a:p>
-            <a:fld id="{FF78EFD2-C9A0-A146-8CE9-0A2B7CC7B867}" type="slidenum">
-              <a:rPr lang="en-US" smtClean="0"/>
-              <a:t>31</a:t>
-            </a:fld>
-            <a:endParaRPr lang="en-US"/>
-          </a:p>
-        </p:txBody>
-      </p:sp>
-    </p:spTree>
-    <p:extLst>
-      <p:ext uri="{BB962C8B-B14F-4D97-AF65-F5344CB8AC3E}">
-        <p14:creationId xmlns:p14="http://schemas.microsoft.com/office/powerpoint/2010/main" val="1675293660"/>
-      </p:ext>
-    </p:extLst>
-  </p:cSld>
-  <p:clrMapOvr>
-    <a:masterClrMapping/>
-  </p:clrMapOvr>
-</p:notes>
-</file>
-
-<file path=ppt/notesSlides/notesSlide32.xml><?xml version="1.0" encoding="utf-8"?>
-<p:notes xmlns:a="http://schemas.openxmlformats.org/drawingml/2006/main" xmlns:r="http://schemas.openxmlformats.org/officeDocument/2006/relationships" xmlns:p="http://schemas.openxmlformats.org/presentationml/2006/main">
-  <p:cSld>
-    <p:spTree>
-      <p:nvGrpSpPr>
-        <p:cNvPr id="1" name=""/>
-        <p:cNvGrpSpPr/>
-        <p:nvPr/>
-      </p:nvGrpSpPr>
-      <p:grpSpPr>
-        <a:xfrm>
-          <a:off x="0" y="0"/>
-          <a:ext cx="0" cy="0"/>
-          <a:chOff x="0" y="0"/>
-          <a:chExt cx="0" cy="0"/>
-        </a:xfrm>
-      </p:grpSpPr>
-      <p:sp>
-        <p:nvSpPr>
-          <p:cNvPr id="2" name="Slide Image Placeholder 1"/>
-          <p:cNvSpPr>
-            <a:spLocks noGrp="1" noRot="1" noChangeAspect="1"/>
-          </p:cNvSpPr>
-          <p:nvPr>
-            <p:ph type="sldImg"/>
-          </p:nvPr>
-        </p:nvSpPr>
-        <p:spPr/>
-      </p:sp>
-      <p:sp>
-        <p:nvSpPr>
-          <p:cNvPr id="3" name="Notes Placeholder 2"/>
-          <p:cNvSpPr>
-            <a:spLocks noGrp="1"/>
-          </p:cNvSpPr>
-          <p:nvPr>
-            <p:ph type="body" idx="1"/>
-          </p:nvPr>
-        </p:nvSpPr>
-        <p:spPr/>
-        <p:txBody>
-          <a:bodyPr/>
-          <a:lstStyle/>
-          <a:p>
-            <a:pPr marL="0" marR="0" lvl="0" indent="0" algn="l" defTabSz="914400" rtl="0" eaLnBrk="1" fontAlgn="auto" latinLnBrk="0" hangingPunct="1">
-              <a:lnSpc>
-                <a:spcPct val="100000"/>
-              </a:lnSpc>
-              <a:spcBef>
-                <a:spcPts val="0"/>
-              </a:spcBef>
-              <a:spcAft>
-                <a:spcPts val="0"/>
-              </a:spcAft>
-              <a:buClrTx/>
-              <a:buSzTx/>
-              <a:buFontTx/>
-              <a:buNone/>
-              <a:tabLst/>
-              <a:defRPr/>
-            </a:pPr>
-            <a:r>
-              <a:rPr lang="en-US" sz="1200" dirty="0">
-                <a:solidFill>
-                  <a:schemeClr val="accent1"/>
-                </a:solidFill>
-              </a:rPr>
-              <a:t>e.g., </a:t>
-            </a:r>
-            <a:r>
-              <a:rPr lang="en-US" sz="1200" dirty="0" err="1">
-                <a:solidFill>
-                  <a:schemeClr val="accent1"/>
-                </a:solidFill>
-              </a:rPr>
-              <a:t>MediaWiki</a:t>
-            </a:r>
-            <a:r>
-              <a:rPr lang="en-US" sz="1200" dirty="0">
-                <a:solidFill>
-                  <a:schemeClr val="accent1"/>
-                </a:solidFill>
-              </a:rPr>
-              <a:t> API: https://</a:t>
-            </a:r>
-            <a:r>
-              <a:rPr lang="en-US" sz="1200" dirty="0" err="1">
-                <a:solidFill>
-                  <a:schemeClr val="accent1"/>
-                </a:solidFill>
-              </a:rPr>
-              <a:t>en.wikipedia.org</a:t>
-            </a:r>
-            <a:r>
-              <a:rPr lang="en-US" sz="1200" dirty="0">
-                <a:solidFill>
-                  <a:schemeClr val="accent1"/>
-                </a:solidFill>
-              </a:rPr>
-              <a:t>/w/</a:t>
-            </a:r>
-            <a:r>
-              <a:rPr lang="en-US" sz="1200" dirty="0" err="1">
-                <a:solidFill>
-                  <a:schemeClr val="accent1"/>
-                </a:solidFill>
-              </a:rPr>
-              <a:t>api.php</a:t>
-            </a:r>
-            <a:endParaRPr lang="en-US" sz="1200" dirty="0">
-              <a:solidFill>
-                <a:schemeClr val="accent1"/>
-              </a:solidFill>
-            </a:endParaRPr>
-          </a:p>
-        </p:txBody>
-      </p:sp>
-      <p:sp>
-        <p:nvSpPr>
-          <p:cNvPr id="4" name="Slide Number Placeholder 3"/>
-          <p:cNvSpPr>
-            <a:spLocks noGrp="1"/>
-          </p:cNvSpPr>
-          <p:nvPr>
-            <p:ph type="sldNum" sz="quarter" idx="5"/>
-          </p:nvPr>
-        </p:nvSpPr>
-        <p:spPr/>
-        <p:txBody>
-          <a:bodyPr/>
-          <a:lstStyle/>
-          <a:p>
-            <a:fld id="{FF78EFD2-C9A0-A146-8CE9-0A2B7CC7B867}" type="slidenum">
-              <a:rPr lang="en-US" smtClean="0"/>
-              <a:t>32</a:t>
-            </a:fld>
-            <a:endParaRPr lang="en-US"/>
-          </a:p>
-        </p:txBody>
-      </p:sp>
-    </p:spTree>
-    <p:extLst>
-      <p:ext uri="{BB962C8B-B14F-4D97-AF65-F5344CB8AC3E}">
-        <p14:creationId xmlns:p14="http://schemas.microsoft.com/office/powerpoint/2010/main" val="3404265225"/>
       </p:ext>
     </p:extLst>
   </p:cSld>
@@ -10286,412 +9600,6 @@
         <p:cNvPr id="1" name="">
           <a:extLst>
             <a:ext uri="{FF2B5EF4-FFF2-40B4-BE49-F238E27FC236}">
-              <a16:creationId xmlns:a16="http://schemas.microsoft.com/office/drawing/2014/main" id="{3F787A8E-2204-AE00-F268-C2A7D74740CC}"/>
-            </a:ext>
-          </a:extLst>
-        </p:cNvPr>
-        <p:cNvGrpSpPr/>
-        <p:nvPr/>
-      </p:nvGrpSpPr>
-      <p:grpSpPr>
-        <a:xfrm>
-          <a:off x="0" y="0"/>
-          <a:ext cx="0" cy="0"/>
-          <a:chOff x="0" y="0"/>
-          <a:chExt cx="0" cy="0"/>
-        </a:xfrm>
-      </p:grpSpPr>
-      <p:sp>
-        <p:nvSpPr>
-          <p:cNvPr id="2" name="Title 1">
-            <a:extLst>
-              <a:ext uri="{FF2B5EF4-FFF2-40B4-BE49-F238E27FC236}">
-                <a16:creationId xmlns:a16="http://schemas.microsoft.com/office/drawing/2014/main" id="{72B26E73-AF84-D637-2F3E-00A03B6A1659}"/>
-              </a:ext>
-            </a:extLst>
-          </p:cNvPr>
-          <p:cNvSpPr>
-            <a:spLocks noGrp="1"/>
-          </p:cNvSpPr>
-          <p:nvPr>
-            <p:ph type="title"/>
-          </p:nvPr>
-        </p:nvSpPr>
-        <p:spPr/>
-        <p:txBody>
-          <a:bodyPr/>
-          <a:lstStyle/>
-          <a:p>
-            <a:r>
-              <a:rPr lang="en-US" dirty="0">
-                <a:solidFill>
-                  <a:schemeClr val="accent1"/>
-                </a:solidFill>
-              </a:rPr>
-              <a:t>Browser Automation</a:t>
-            </a:r>
-          </a:p>
-        </p:txBody>
-      </p:sp>
-      <p:sp>
-        <p:nvSpPr>
-          <p:cNvPr id="3" name="Content Placeholder 2">
-            <a:extLst>
-              <a:ext uri="{FF2B5EF4-FFF2-40B4-BE49-F238E27FC236}">
-                <a16:creationId xmlns:a16="http://schemas.microsoft.com/office/drawing/2014/main" id="{DC647414-CC22-620D-B647-80F20AED8484}"/>
-              </a:ext>
-            </a:extLst>
-          </p:cNvPr>
-          <p:cNvSpPr>
-            <a:spLocks noGrp="1"/>
-          </p:cNvSpPr>
-          <p:nvPr>
-            <p:ph idx="1"/>
-          </p:nvPr>
-        </p:nvSpPr>
-        <p:spPr>
-          <a:xfrm>
-            <a:off x="838200" y="1720525"/>
-            <a:ext cx="5257800" cy="4351338"/>
-          </a:xfrm>
-        </p:spPr>
-        <p:txBody>
-          <a:bodyPr/>
-          <a:lstStyle/>
-          <a:p>
-            <a:pPr marL="0" indent="0">
-              <a:buNone/>
-            </a:pPr>
-            <a:r>
-              <a:rPr lang="en-US" dirty="0">
-                <a:solidFill>
-                  <a:schemeClr val="accent1"/>
-                </a:solidFill>
-              </a:rPr>
-              <a:t>Useful when:</a:t>
-            </a:r>
-          </a:p>
-          <a:p>
-            <a:r>
-              <a:rPr lang="en-US" sz="2400" dirty="0">
-                <a:solidFill>
-                  <a:schemeClr val="accent1"/>
-                </a:solidFill>
-              </a:rPr>
-              <a:t>designed for transparency</a:t>
-            </a:r>
-          </a:p>
-          <a:p>
-            <a:r>
-              <a:rPr lang="en-US" sz="2400" dirty="0">
-                <a:solidFill>
-                  <a:schemeClr val="accent1"/>
-                </a:solidFill>
-              </a:rPr>
-              <a:t>often searchable</a:t>
-            </a:r>
-          </a:p>
-          <a:p>
-            <a:r>
-              <a:rPr lang="en-US" sz="2400" dirty="0">
-                <a:solidFill>
-                  <a:schemeClr val="accent1"/>
-                </a:solidFill>
-              </a:rPr>
-              <a:t>useful for moderation or advertising research</a:t>
-            </a:r>
-          </a:p>
-          <a:p>
-            <a:pPr marL="0" indent="0">
-              <a:buNone/>
-            </a:pPr>
-            <a:endParaRPr lang="en-US" dirty="0">
-              <a:solidFill>
-                <a:schemeClr val="accent1"/>
-              </a:solidFill>
-            </a:endParaRPr>
-          </a:p>
-        </p:txBody>
-      </p:sp>
-      <p:sp>
-        <p:nvSpPr>
-          <p:cNvPr id="4" name="Content Placeholder 2">
-            <a:extLst>
-              <a:ext uri="{FF2B5EF4-FFF2-40B4-BE49-F238E27FC236}">
-                <a16:creationId xmlns:a16="http://schemas.microsoft.com/office/drawing/2014/main" id="{7EDF7131-4FA3-1492-916A-4DC38587AAA1}"/>
-              </a:ext>
-            </a:extLst>
-          </p:cNvPr>
-          <p:cNvSpPr txBox="1">
-            <a:spLocks/>
-          </p:cNvSpPr>
-          <p:nvPr/>
-        </p:nvSpPr>
-        <p:spPr>
-          <a:xfrm>
-            <a:off x="6095999" y="1690688"/>
-            <a:ext cx="5802775" cy="4351338"/>
-          </a:xfrm>
-          <a:prstGeom prst="rect">
-            <a:avLst/>
-          </a:prstGeom>
-        </p:spPr>
-        <p:txBody>
-          <a:bodyPr vert="horz" lIns="91440" tIns="45720" rIns="91440" bIns="45720" rtlCol="0">
-            <a:normAutofit/>
-          </a:bodyPr>
-          <a:lstStyle>
-            <a:lvl1pPr marL="228600" indent="-228600" algn="l" defTabSz="914400" rtl="0" eaLnBrk="1" latinLnBrk="0" hangingPunct="1">
-              <a:lnSpc>
-                <a:spcPct val="90000"/>
-              </a:lnSpc>
-              <a:spcBef>
-                <a:spcPts val="1000"/>
-              </a:spcBef>
-              <a:buFont typeface="Arial" panose="020B0604020202020204" pitchFamily="34" charset="0"/>
-              <a:buChar char="•"/>
-              <a:defRPr sz="2800" kern="1200">
-                <a:solidFill>
-                  <a:schemeClr val="tx1"/>
-                </a:solidFill>
-                <a:latin typeface="+mn-lt"/>
-                <a:ea typeface="+mn-ea"/>
-                <a:cs typeface="+mn-cs"/>
-              </a:defRPr>
-            </a:lvl1pPr>
-            <a:lvl2pPr marL="685800" indent="-228600" algn="l" defTabSz="914400" rtl="0" eaLnBrk="1" latinLnBrk="0" hangingPunct="1">
-              <a:lnSpc>
-                <a:spcPct val="90000"/>
-              </a:lnSpc>
-              <a:spcBef>
-                <a:spcPts val="500"/>
-              </a:spcBef>
-              <a:buFont typeface="Arial" panose="020B0604020202020204" pitchFamily="34" charset="0"/>
-              <a:buChar char="•"/>
-              <a:defRPr sz="2400" kern="1200">
-                <a:solidFill>
-                  <a:schemeClr val="tx1"/>
-                </a:solidFill>
-                <a:latin typeface="+mn-lt"/>
-                <a:ea typeface="+mn-ea"/>
-                <a:cs typeface="+mn-cs"/>
-              </a:defRPr>
-            </a:lvl2pPr>
-            <a:lvl3pPr marL="1143000" indent="-228600" algn="l" defTabSz="914400" rtl="0" eaLnBrk="1" latinLnBrk="0" hangingPunct="1">
-              <a:lnSpc>
-                <a:spcPct val="90000"/>
-              </a:lnSpc>
-              <a:spcBef>
-                <a:spcPts val="500"/>
-              </a:spcBef>
-              <a:buFont typeface="Arial" panose="020B0604020202020204" pitchFamily="34" charset="0"/>
-              <a:buChar char="•"/>
-              <a:defRPr sz="2000" kern="1200">
-                <a:solidFill>
-                  <a:schemeClr val="tx1"/>
-                </a:solidFill>
-                <a:latin typeface="+mn-lt"/>
-                <a:ea typeface="+mn-ea"/>
-                <a:cs typeface="+mn-cs"/>
-              </a:defRPr>
-            </a:lvl3pPr>
-            <a:lvl4pPr marL="1600200" indent="-228600" algn="l" defTabSz="914400" rtl="0" eaLnBrk="1" latinLnBrk="0" hangingPunct="1">
-              <a:lnSpc>
-                <a:spcPct val="90000"/>
-              </a:lnSpc>
-              <a:spcBef>
-                <a:spcPts val="500"/>
-              </a:spcBef>
-              <a:buFont typeface="Arial" panose="020B0604020202020204" pitchFamily="34" charset="0"/>
-              <a:buChar char="•"/>
-              <a:defRPr sz="1800" kern="1200">
-                <a:solidFill>
-                  <a:schemeClr val="tx1"/>
-                </a:solidFill>
-                <a:latin typeface="+mn-lt"/>
-                <a:ea typeface="+mn-ea"/>
-                <a:cs typeface="+mn-cs"/>
-              </a:defRPr>
-            </a:lvl4pPr>
-            <a:lvl5pPr marL="2057400" indent="-228600" algn="l" defTabSz="914400" rtl="0" eaLnBrk="1" latinLnBrk="0" hangingPunct="1">
-              <a:lnSpc>
-                <a:spcPct val="90000"/>
-              </a:lnSpc>
-              <a:spcBef>
-                <a:spcPts val="500"/>
-              </a:spcBef>
-              <a:buFont typeface="Arial" panose="020B0604020202020204" pitchFamily="34" charset="0"/>
-              <a:buChar char="•"/>
-              <a:defRPr sz="1800" kern="1200">
-                <a:solidFill>
-                  <a:schemeClr val="tx1"/>
-                </a:solidFill>
-                <a:latin typeface="+mn-lt"/>
-                <a:ea typeface="+mn-ea"/>
-                <a:cs typeface="+mn-cs"/>
-              </a:defRPr>
-            </a:lvl5pPr>
-            <a:lvl6pPr marL="2514600" indent="-228600" algn="l" defTabSz="914400" rtl="0" eaLnBrk="1" latinLnBrk="0" hangingPunct="1">
-              <a:lnSpc>
-                <a:spcPct val="90000"/>
-              </a:lnSpc>
-              <a:spcBef>
-                <a:spcPts val="500"/>
-              </a:spcBef>
-              <a:buFont typeface="Arial" panose="020B0604020202020204" pitchFamily="34" charset="0"/>
-              <a:buChar char="•"/>
-              <a:defRPr sz="1800" kern="1200">
-                <a:solidFill>
-                  <a:schemeClr val="tx1"/>
-                </a:solidFill>
-                <a:latin typeface="+mn-lt"/>
-                <a:ea typeface="+mn-ea"/>
-                <a:cs typeface="+mn-cs"/>
-              </a:defRPr>
-            </a:lvl6pPr>
-            <a:lvl7pPr marL="2971800" indent="-228600" algn="l" defTabSz="914400" rtl="0" eaLnBrk="1" latinLnBrk="0" hangingPunct="1">
-              <a:lnSpc>
-                <a:spcPct val="90000"/>
-              </a:lnSpc>
-              <a:spcBef>
-                <a:spcPts val="500"/>
-              </a:spcBef>
-              <a:buFont typeface="Arial" panose="020B0604020202020204" pitchFamily="34" charset="0"/>
-              <a:buChar char="•"/>
-              <a:defRPr sz="1800" kern="1200">
-                <a:solidFill>
-                  <a:schemeClr val="tx1"/>
-                </a:solidFill>
-                <a:latin typeface="+mn-lt"/>
-                <a:ea typeface="+mn-ea"/>
-                <a:cs typeface="+mn-cs"/>
-              </a:defRPr>
-            </a:lvl7pPr>
-            <a:lvl8pPr marL="3429000" indent="-228600" algn="l" defTabSz="914400" rtl="0" eaLnBrk="1" latinLnBrk="0" hangingPunct="1">
-              <a:lnSpc>
-                <a:spcPct val="90000"/>
-              </a:lnSpc>
-              <a:spcBef>
-                <a:spcPts val="500"/>
-              </a:spcBef>
-              <a:buFont typeface="Arial" panose="020B0604020202020204" pitchFamily="34" charset="0"/>
-              <a:buChar char="•"/>
-              <a:defRPr sz="1800" kern="1200">
-                <a:solidFill>
-                  <a:schemeClr val="tx1"/>
-                </a:solidFill>
-                <a:latin typeface="+mn-lt"/>
-                <a:ea typeface="+mn-ea"/>
-                <a:cs typeface="+mn-cs"/>
-              </a:defRPr>
-            </a:lvl8pPr>
-            <a:lvl9pPr marL="3886200" indent="-228600" algn="l" defTabSz="914400" rtl="0" eaLnBrk="1" latinLnBrk="0" hangingPunct="1">
-              <a:lnSpc>
-                <a:spcPct val="90000"/>
-              </a:lnSpc>
-              <a:spcBef>
-                <a:spcPts val="500"/>
-              </a:spcBef>
-              <a:buFont typeface="Arial" panose="020B0604020202020204" pitchFamily="34" charset="0"/>
-              <a:buChar char="•"/>
-              <a:defRPr sz="1800" kern="1200">
-                <a:solidFill>
-                  <a:schemeClr val="tx1"/>
-                </a:solidFill>
-                <a:latin typeface="+mn-lt"/>
-                <a:ea typeface="+mn-ea"/>
-                <a:cs typeface="+mn-cs"/>
-              </a:defRPr>
-            </a:lvl9pPr>
-          </a:lstStyle>
-          <a:p>
-            <a:pPr marL="0" indent="0">
-              <a:buFont typeface="Arial" panose="020B0604020202020204" pitchFamily="34" charset="0"/>
-              <a:buNone/>
-            </a:pPr>
-            <a:r>
-              <a:rPr lang="en-US" dirty="0">
-                <a:solidFill>
-                  <a:schemeClr val="accent1"/>
-                </a:solidFill>
-              </a:rPr>
-              <a:t>Limitations:</a:t>
-            </a:r>
-          </a:p>
-          <a:p>
-            <a:r>
-              <a:rPr lang="en-US" sz="2400" dirty="0">
-                <a:solidFill>
-                  <a:schemeClr val="accent1"/>
-                </a:solidFill>
-              </a:rPr>
-              <a:t>slower and more brittle</a:t>
-            </a:r>
-          </a:p>
-          <a:p>
-            <a:r>
-              <a:rPr lang="en-US" sz="2400" dirty="0">
-                <a:solidFill>
-                  <a:schemeClr val="accent1"/>
-                </a:solidFill>
-              </a:rPr>
-              <a:t>more server load</a:t>
-            </a:r>
-          </a:p>
-          <a:p>
-            <a:r>
-              <a:rPr lang="en-US" sz="2400" dirty="0">
-                <a:solidFill>
-                  <a:schemeClr val="accent1"/>
-                </a:solidFill>
-              </a:rPr>
-              <a:t>waiting/scrolling choices can affect results</a:t>
-            </a:r>
-          </a:p>
-          <a:p>
-            <a:r>
-              <a:rPr lang="en-US" sz="2400" dirty="0">
-                <a:solidFill>
-                  <a:schemeClr val="accent1"/>
-                </a:solidFill>
-              </a:rPr>
-              <a:t>should not be used to bypass controls</a:t>
-            </a:r>
-          </a:p>
-          <a:p>
-            <a:pPr marL="0" indent="0">
-              <a:buFont typeface="Arial" panose="020B0604020202020204" pitchFamily="34" charset="0"/>
-              <a:buNone/>
-            </a:pPr>
-            <a:endParaRPr lang="en-US" dirty="0">
-              <a:solidFill>
-                <a:schemeClr val="accent1"/>
-              </a:solidFill>
-            </a:endParaRPr>
-          </a:p>
-        </p:txBody>
-      </p:sp>
-    </p:spTree>
-    <p:extLst>
-      <p:ext uri="{BB962C8B-B14F-4D97-AF65-F5344CB8AC3E}">
-        <p14:creationId xmlns:p14="http://schemas.microsoft.com/office/powerpoint/2010/main" val="1630702811"/>
-      </p:ext>
-    </p:extLst>
-  </p:cSld>
-  <p:clrMapOvr>
-    <a:masterClrMapping/>
-  </p:clrMapOvr>
-</p:sld>
-</file>
-
-<file path=ppt/slides/slide22.xml><?xml version="1.0" encoding="utf-8"?>
-<p:sld xmlns:a="http://schemas.openxmlformats.org/drawingml/2006/main" xmlns:r="http://schemas.openxmlformats.org/officeDocument/2006/relationships" xmlns:p="http://schemas.openxmlformats.org/presentationml/2006/main">
-  <p:cSld>
-    <p:spTree>
-      <p:nvGrpSpPr>
-        <p:cNvPr id="1" name="">
-          <a:extLst>
-            <a:ext uri="{FF2B5EF4-FFF2-40B4-BE49-F238E27FC236}">
               <a16:creationId xmlns:a16="http://schemas.microsoft.com/office/drawing/2014/main" id="{5BA09BAB-22A5-24C5-CB63-2D9170A38179}"/>
             </a:ext>
           </a:extLst>
@@ -10855,7 +9763,7 @@
 </p:sld>
 </file>
 
-<file path=ppt/slides/slide23.xml><?xml version="1.0" encoding="utf-8"?>
+<file path=ppt/slides/slide22.xml><?xml version="1.0" encoding="utf-8"?>
 <p:sld xmlns:a="http://schemas.openxmlformats.org/drawingml/2006/main" xmlns:r="http://schemas.openxmlformats.org/officeDocument/2006/relationships" xmlns:p="http://schemas.openxmlformats.org/presentationml/2006/main">
   <p:cSld>
     <p:spTree>
@@ -11261,7 +10169,7 @@
 </p:sld>
 </file>
 
-<file path=ppt/slides/slide24.xml><?xml version="1.0" encoding="utf-8"?>
+<file path=ppt/slides/slide23.xml><?xml version="1.0" encoding="utf-8"?>
 <p:sld xmlns:a="http://schemas.openxmlformats.org/drawingml/2006/main" xmlns:r="http://schemas.openxmlformats.org/officeDocument/2006/relationships" xmlns:p="http://schemas.openxmlformats.org/presentationml/2006/main">
   <p:cSld>
     <p:spTree>
@@ -11432,191 +10340,7 @@
 </p:sld>
 </file>
 
-<file path=ppt/slides/slide25.xml><?xml version="1.0" encoding="utf-8"?>
-<p:sld xmlns:a="http://schemas.openxmlformats.org/drawingml/2006/main" xmlns:r="http://schemas.openxmlformats.org/officeDocument/2006/relationships" xmlns:p="http://schemas.openxmlformats.org/presentationml/2006/main">
-  <p:cSld>
-    <p:spTree>
-      <p:nvGrpSpPr>
-        <p:cNvPr id="1" name="">
-          <a:extLst>
-            <a:ext uri="{FF2B5EF4-FFF2-40B4-BE49-F238E27FC236}">
-              <a16:creationId xmlns:a16="http://schemas.microsoft.com/office/drawing/2014/main" id="{25A4D19A-D1AC-734D-087B-BF8CDF1B503B}"/>
-            </a:ext>
-          </a:extLst>
-        </p:cNvPr>
-        <p:cNvGrpSpPr/>
-        <p:nvPr/>
-      </p:nvGrpSpPr>
-      <p:grpSpPr>
-        <a:xfrm>
-          <a:off x="0" y="0"/>
-          <a:ext cx="0" cy="0"/>
-          <a:chOff x="0" y="0"/>
-          <a:chExt cx="0" cy="0"/>
-        </a:xfrm>
-      </p:grpSpPr>
-      <p:sp>
-        <p:nvSpPr>
-          <p:cNvPr id="2" name="Title 1">
-            <a:extLst>
-              <a:ext uri="{FF2B5EF4-FFF2-40B4-BE49-F238E27FC236}">
-                <a16:creationId xmlns:a16="http://schemas.microsoft.com/office/drawing/2014/main" id="{36467E2C-DC9D-427E-D36F-8CEFFA7DC1FF}"/>
-              </a:ext>
-            </a:extLst>
-          </p:cNvPr>
-          <p:cNvSpPr>
-            <a:spLocks noGrp="1"/>
-          </p:cNvSpPr>
-          <p:nvPr>
-            <p:ph type="title"/>
-          </p:nvPr>
-        </p:nvSpPr>
-        <p:spPr/>
-        <p:txBody>
-          <a:bodyPr/>
-          <a:lstStyle/>
-          <a:p>
-            <a:r>
-              <a:rPr lang="en-US" dirty="0">
-                <a:solidFill>
-                  <a:schemeClr val="accent1"/>
-                </a:solidFill>
-              </a:rPr>
-              <a:t>DSA-Based Researcher Access</a:t>
-            </a:r>
-          </a:p>
-        </p:txBody>
-      </p:sp>
-      <p:sp>
-        <p:nvSpPr>
-          <p:cNvPr id="3" name="Content Placeholder 2">
-            <a:extLst>
-              <a:ext uri="{FF2B5EF4-FFF2-40B4-BE49-F238E27FC236}">
-                <a16:creationId xmlns:a16="http://schemas.microsoft.com/office/drawing/2014/main" id="{DC2A80F6-A8C3-8F78-6B07-8F01F4356013}"/>
-              </a:ext>
-            </a:extLst>
-          </p:cNvPr>
-          <p:cNvSpPr>
-            <a:spLocks noGrp="1"/>
-          </p:cNvSpPr>
-          <p:nvPr>
-            <p:ph idx="1"/>
-          </p:nvPr>
-        </p:nvSpPr>
-        <p:spPr>
-          <a:xfrm>
-            <a:off x="838200" y="1720525"/>
-            <a:ext cx="10515600" cy="4351338"/>
-          </a:xfrm>
-        </p:spPr>
-        <p:txBody>
-          <a:bodyPr/>
-          <a:lstStyle/>
-          <a:p>
-            <a:pPr marL="0" indent="0">
-              <a:buNone/>
-            </a:pPr>
-            <a:r>
-              <a:rPr lang="en-US" dirty="0">
-                <a:solidFill>
-                  <a:schemeClr val="accent1"/>
-                </a:solidFill>
-              </a:rPr>
-              <a:t>The Digital Services Act (DSA) creates access mechanisms for studying systemic risks.</a:t>
-            </a:r>
-          </a:p>
-          <a:p>
-            <a:pPr marL="0" indent="0">
-              <a:buNone/>
-            </a:pPr>
-            <a:endParaRPr lang="en-US" dirty="0">
-              <a:solidFill>
-                <a:schemeClr val="accent1"/>
-              </a:solidFill>
-            </a:endParaRPr>
-          </a:p>
-          <a:p>
-            <a:pPr marL="0" indent="0">
-              <a:buNone/>
-            </a:pPr>
-            <a:r>
-              <a:rPr lang="en-US" dirty="0">
-                <a:solidFill>
-                  <a:schemeClr val="accent1"/>
-                </a:solidFill>
-              </a:rPr>
-              <a:t>Relevant distinction:</a:t>
-            </a:r>
-          </a:p>
-          <a:p>
-            <a:r>
-              <a:rPr lang="en-US" sz="2400" dirty="0">
-                <a:solidFill>
-                  <a:schemeClr val="accent1"/>
-                </a:solidFill>
-              </a:rPr>
-              <a:t>public-data access</a:t>
-            </a:r>
-          </a:p>
-          <a:p>
-            <a:r>
-              <a:rPr lang="en-US" sz="2400" dirty="0">
-                <a:solidFill>
-                  <a:schemeClr val="accent1"/>
-                </a:solidFill>
-              </a:rPr>
-              <a:t>vetted researcher access to non-public data</a:t>
-            </a:r>
-          </a:p>
-          <a:p>
-            <a:pPr marL="0" indent="0">
-              <a:buNone/>
-            </a:pPr>
-            <a:endParaRPr lang="en-US" dirty="0">
-              <a:solidFill>
-                <a:schemeClr val="accent1"/>
-              </a:solidFill>
-            </a:endParaRPr>
-          </a:p>
-          <a:p>
-            <a:pPr marL="0" indent="0">
-              <a:buNone/>
-            </a:pPr>
-            <a:r>
-              <a:rPr lang="en-US" dirty="0">
-                <a:solidFill>
-                  <a:schemeClr val="accent1"/>
-                </a:solidFill>
-              </a:rPr>
-              <a:t>More by Hajo Boomgaarden on Thursday!</a:t>
-            </a:r>
-          </a:p>
-          <a:p>
-            <a:pPr marL="0" indent="0">
-              <a:buNone/>
-            </a:pPr>
-            <a:endParaRPr lang="en-US" dirty="0">
-              <a:solidFill>
-                <a:schemeClr val="accent1"/>
-              </a:solidFill>
-            </a:endParaRPr>
-          </a:p>
-        </p:txBody>
-      </p:sp>
-    </p:spTree>
-    <p:extLst>
-      <p:ext uri="{BB962C8B-B14F-4D97-AF65-F5344CB8AC3E}">
-        <p14:creationId xmlns:p14="http://schemas.microsoft.com/office/powerpoint/2010/main" val="3853719236"/>
-      </p:ext>
-    </p:extLst>
-  </p:cSld>
-  <p:clrMapOvr>
-    <a:masterClrMapping/>
-  </p:clrMapOvr>
-</p:sld>
-</file>
-
-<file path=ppt/slides/slide26.xml><?xml version="1.0" encoding="utf-8"?>
+<file path=ppt/slides/slide24.xml><?xml version="1.0" encoding="utf-8"?>
 <p:sld xmlns:a="http://schemas.openxmlformats.org/drawingml/2006/main" xmlns:r="http://schemas.openxmlformats.org/officeDocument/2006/relationships" xmlns:p="http://schemas.openxmlformats.org/presentationml/2006/main">
   <p:cSld>
     <p:spTree>
@@ -11751,7 +10475,7 @@
 </p:sld>
 </file>
 
-<file path=ppt/slides/slide27.xml><?xml version="1.0" encoding="utf-8"?>
+<file path=ppt/slides/slide25.xml><?xml version="1.0" encoding="utf-8"?>
 <p:sld xmlns:a="http://schemas.openxmlformats.org/drawingml/2006/main" xmlns:r="http://schemas.openxmlformats.org/officeDocument/2006/relationships" xmlns:p="http://schemas.openxmlformats.org/presentationml/2006/main">
   <p:cSld>
     <p:spTree>
@@ -11878,7 +10602,7 @@
 </p:sld>
 </file>
 
-<file path=ppt/slides/slide28.xml><?xml version="1.0" encoding="utf-8"?>
+<file path=ppt/slides/slide26.xml><?xml version="1.0" encoding="utf-8"?>
 <p:sld xmlns:a="http://schemas.openxmlformats.org/drawingml/2006/main" xmlns:r="http://schemas.openxmlformats.org/officeDocument/2006/relationships" xmlns:p="http://schemas.openxmlformats.org/presentationml/2006/main">
   <p:cSld>
     <p:spTree>
@@ -12016,7 +10740,7 @@
 </p:sld>
 </file>
 
-<file path=ppt/slides/slide29.xml><?xml version="1.0" encoding="utf-8"?>
+<file path=ppt/slides/slide27.xml><?xml version="1.0" encoding="utf-8"?>
 <p:sld xmlns:a="http://schemas.openxmlformats.org/drawingml/2006/main" xmlns:r="http://schemas.openxmlformats.org/officeDocument/2006/relationships" xmlns:p="http://schemas.openxmlformats.org/presentationml/2006/main">
   <p:cSld>
     <p:spTree>
@@ -12024,7 +10748,7 @@
         <p:cNvPr id="1" name="">
           <a:extLst>
             <a:ext uri="{FF2B5EF4-FFF2-40B4-BE49-F238E27FC236}">
-              <a16:creationId xmlns:a16="http://schemas.microsoft.com/office/drawing/2014/main" id="{F84301E6-1F94-2F12-668A-B5414CDBD5F0}"/>
+              <a16:creationId xmlns:a16="http://schemas.microsoft.com/office/drawing/2014/main" id="{A58260FE-ECFF-0268-05BA-97F7BA8F571F}"/>
             </a:ext>
           </a:extLst>
         </p:cNvPr>
@@ -12044,7 +10768,7 @@
           <p:cNvPr id="2" name="Title 1">
             <a:extLst>
               <a:ext uri="{FF2B5EF4-FFF2-40B4-BE49-F238E27FC236}">
-                <a16:creationId xmlns:a16="http://schemas.microsoft.com/office/drawing/2014/main" id="{D6D55418-86A3-AAAE-46DE-A13686D23F80}"/>
+                <a16:creationId xmlns:a16="http://schemas.microsoft.com/office/drawing/2014/main" id="{F26F5233-FD9F-505B-FDDB-8ED2028034D1}"/>
               </a:ext>
             </a:extLst>
           </p:cNvPr>
@@ -12066,7 +10790,7 @@
                   <a:schemeClr val="accent1"/>
                 </a:solidFill>
               </a:rPr>
-              <a:t>What is an API?</a:t>
+              <a:t>How APIs Work</a:t>
             </a:r>
           </a:p>
         </p:txBody>
@@ -12076,7 +10800,7 @@
           <p:cNvPr id="3" name="Content Placeholder 2">
             <a:extLst>
               <a:ext uri="{FF2B5EF4-FFF2-40B4-BE49-F238E27FC236}">
-                <a16:creationId xmlns:a16="http://schemas.microsoft.com/office/drawing/2014/main" id="{BC4F1094-314C-62A1-A2F9-4D33D618CBC2}"/>
+                <a16:creationId xmlns:a16="http://schemas.microsoft.com/office/drawing/2014/main" id="{1253A800-82C6-501F-EC81-0E4693AF784C}"/>
               </a:ext>
             </a:extLst>
           </p:cNvPr>
@@ -12101,50 +10825,330 @@
               <a:buNone/>
             </a:pPr>
             <a:r>
-              <a:rPr lang="en-US" dirty="0">
-                <a:solidFill>
-                  <a:schemeClr val="accent1"/>
-                </a:solidFill>
-              </a:rPr>
-              <a:t>API = Application Programming Interface, i.e., a way for software systems to communicate.</a:t>
-            </a:r>
-          </a:p>
-        </p:txBody>
-      </p:sp>
-      <p:pic>
-        <p:nvPicPr>
-          <p:cNvPr id="4" name="Picture 3" descr="frame_3259.webp">
-            <a:extLst>
-              <a:ext uri="{FF2B5EF4-FFF2-40B4-BE49-F238E27FC236}">
-                <a16:creationId xmlns:a16="http://schemas.microsoft.com/office/drawing/2014/main" id="{5A47F343-33D8-0A3E-00EB-802CB1D011D2}"/>
-              </a:ext>
-            </a:extLst>
-          </p:cNvPr>
-          <p:cNvPicPr>
-            <a:picLocks noChangeAspect="1"/>
-          </p:cNvPicPr>
-          <p:nvPr/>
-        </p:nvPicPr>
-        <p:blipFill>
-          <a:blip r:embed="rId3"/>
-          <a:stretch>
-            <a:fillRect/>
-          </a:stretch>
-        </p:blipFill>
-        <p:spPr>
-          <a:xfrm>
-            <a:off x="3558059" y="2912766"/>
-            <a:ext cx="5080000" cy="2540000"/>
-          </a:xfrm>
-          <a:prstGeom prst="rect">
-            <a:avLst/>
-          </a:prstGeom>
-        </p:spPr>
-      </p:pic>
+              <a:rPr lang="en-US" sz="2400" dirty="0">
+                <a:solidFill>
+                  <a:schemeClr val="accent1"/>
+                </a:solidFill>
+              </a:rPr>
+              <a:t>APIs operate through a request response cycle between a client and a server</a:t>
+            </a:r>
+          </a:p>
+          <a:p>
+            <a:pPr marL="0" indent="0">
+              <a:buNone/>
+            </a:pPr>
+            <a:endParaRPr lang="en-US" sz="2400" dirty="0">
+              <a:solidFill>
+                <a:schemeClr val="accent1"/>
+              </a:solidFill>
+            </a:endParaRPr>
+          </a:p>
+          <a:p>
+            <a:r>
+              <a:rPr lang="en-US" sz="2400" b="1" dirty="0">
+                <a:solidFill>
+                  <a:schemeClr val="accent1"/>
+                </a:solidFill>
+              </a:rPr>
+              <a:t>Request</a:t>
+            </a:r>
+            <a:r>
+              <a:rPr lang="en-US" sz="2400" dirty="0">
+                <a:solidFill>
+                  <a:schemeClr val="accent1"/>
+                </a:solidFill>
+              </a:rPr>
+              <a:t>: The client sends a request to an API endpoint (URI).</a:t>
+            </a:r>
+          </a:p>
+          <a:p>
+            <a:r>
+              <a:rPr lang="en-US" sz="2400" b="1" dirty="0">
+                <a:solidFill>
+                  <a:schemeClr val="accent1"/>
+                </a:solidFill>
+              </a:rPr>
+              <a:t>Processing</a:t>
+            </a:r>
+            <a:r>
+              <a:rPr lang="en-US" sz="2400" dirty="0">
+                <a:solidFill>
+                  <a:schemeClr val="accent1"/>
+                </a:solidFill>
+              </a:rPr>
+              <a:t>: The API forwards the request to the server.</a:t>
+            </a:r>
+          </a:p>
+          <a:p>
+            <a:r>
+              <a:rPr lang="en-US" sz="2400" b="1" dirty="0">
+                <a:solidFill>
+                  <a:schemeClr val="accent1"/>
+                </a:solidFill>
+              </a:rPr>
+              <a:t>Response</a:t>
+            </a:r>
+            <a:r>
+              <a:rPr lang="en-US" sz="2400" dirty="0">
+                <a:solidFill>
+                  <a:schemeClr val="accent1"/>
+                </a:solidFill>
+              </a:rPr>
+              <a:t>: The server processes and sends back the requested data.</a:t>
+            </a:r>
+          </a:p>
+          <a:p>
+            <a:r>
+              <a:rPr lang="en-US" sz="2400" b="1" dirty="0">
+                <a:solidFill>
+                  <a:schemeClr val="accent1"/>
+                </a:solidFill>
+              </a:rPr>
+              <a:t>Delivery</a:t>
+            </a:r>
+            <a:r>
+              <a:rPr lang="en-US" sz="2400" dirty="0">
+                <a:solidFill>
+                  <a:schemeClr val="accent1"/>
+                </a:solidFill>
+              </a:rPr>
+              <a:t>: The API returns the server’s response to the client.</a:t>
+            </a:r>
+          </a:p>
+          <a:p>
+            <a:pPr marL="0" indent="0">
+              <a:buNone/>
+            </a:pPr>
+            <a:endParaRPr lang="en-US" sz="2400" dirty="0">
+              <a:solidFill>
+                <a:schemeClr val="accent1"/>
+              </a:solidFill>
+            </a:endParaRPr>
+          </a:p>
+          <a:p>
+            <a:pPr marL="0" indent="0">
+              <a:buNone/>
+            </a:pPr>
+            <a:endParaRPr lang="en-US" sz="2400" dirty="0">
+              <a:solidFill>
+                <a:schemeClr val="accent1"/>
+              </a:solidFill>
+            </a:endParaRPr>
+          </a:p>
+        </p:txBody>
+      </p:sp>
     </p:spTree>
     <p:extLst>
       <p:ext uri="{BB962C8B-B14F-4D97-AF65-F5344CB8AC3E}">
-        <p14:creationId xmlns:p14="http://schemas.microsoft.com/office/powerpoint/2010/main" val="1341086130"/>
+        <p14:creationId xmlns:p14="http://schemas.microsoft.com/office/powerpoint/2010/main" val="490620624"/>
+      </p:ext>
+    </p:extLst>
+  </p:cSld>
+  <p:clrMapOvr>
+    <a:masterClrMapping/>
+  </p:clrMapOvr>
+</p:sld>
+</file>
+
+<file path=ppt/slides/slide28.xml><?xml version="1.0" encoding="utf-8"?>
+<p:sld xmlns:a="http://schemas.openxmlformats.org/drawingml/2006/main" xmlns:r="http://schemas.openxmlformats.org/officeDocument/2006/relationships" xmlns:p="http://schemas.openxmlformats.org/presentationml/2006/main">
+  <p:cSld>
+    <p:spTree>
+      <p:nvGrpSpPr>
+        <p:cNvPr id="1" name="">
+          <a:extLst>
+            <a:ext uri="{FF2B5EF4-FFF2-40B4-BE49-F238E27FC236}">
+              <a16:creationId xmlns:a16="http://schemas.microsoft.com/office/drawing/2014/main" id="{041C1123-DECD-4079-C438-2430965C355C}"/>
+            </a:ext>
+          </a:extLst>
+        </p:cNvPr>
+        <p:cNvGrpSpPr/>
+        <p:nvPr/>
+      </p:nvGrpSpPr>
+      <p:grpSpPr>
+        <a:xfrm>
+          <a:off x="0" y="0"/>
+          <a:ext cx="0" cy="0"/>
+          <a:chOff x="0" y="0"/>
+          <a:chExt cx="0" cy="0"/>
+        </a:xfrm>
+      </p:grpSpPr>
+      <p:sp>
+        <p:nvSpPr>
+          <p:cNvPr id="2" name="Title 1">
+            <a:extLst>
+              <a:ext uri="{FF2B5EF4-FFF2-40B4-BE49-F238E27FC236}">
+                <a16:creationId xmlns:a16="http://schemas.microsoft.com/office/drawing/2014/main" id="{A28EBC7E-8309-FCF2-B52B-F2D348C66A07}"/>
+              </a:ext>
+            </a:extLst>
+          </p:cNvPr>
+          <p:cNvSpPr>
+            <a:spLocks noGrp="1"/>
+          </p:cNvSpPr>
+          <p:nvPr>
+            <p:ph type="title"/>
+          </p:nvPr>
+        </p:nvSpPr>
+        <p:spPr/>
+        <p:txBody>
+          <a:bodyPr/>
+          <a:lstStyle/>
+          <a:p>
+            <a:r>
+              <a:rPr lang="en-US" dirty="0">
+                <a:solidFill>
+                  <a:schemeClr val="accent1"/>
+                </a:solidFill>
+              </a:rPr>
+              <a:t>Anatomy of an API request</a:t>
+            </a:r>
+          </a:p>
+        </p:txBody>
+      </p:sp>
+      <p:sp>
+        <p:nvSpPr>
+          <p:cNvPr id="3" name="Content Placeholder 2">
+            <a:extLst>
+              <a:ext uri="{FF2B5EF4-FFF2-40B4-BE49-F238E27FC236}">
+                <a16:creationId xmlns:a16="http://schemas.microsoft.com/office/drawing/2014/main" id="{300F8743-820D-4C7B-CC96-CEFB7B708F76}"/>
+              </a:ext>
+            </a:extLst>
+          </p:cNvPr>
+          <p:cNvSpPr>
+            <a:spLocks noGrp="1"/>
+          </p:cNvSpPr>
+          <p:nvPr>
+            <p:ph idx="1"/>
+          </p:nvPr>
+        </p:nvSpPr>
+        <p:spPr>
+          <a:xfrm>
+            <a:off x="838200" y="1720525"/>
+            <a:ext cx="10515600" cy="4351338"/>
+          </a:xfrm>
+        </p:spPr>
+        <p:txBody>
+          <a:bodyPr/>
+          <a:lstStyle/>
+          <a:p>
+            <a:pPr marL="0" indent="0">
+              <a:buNone/>
+            </a:pPr>
+            <a:r>
+              <a:rPr lang="en-US" dirty="0">
+                <a:solidFill>
+                  <a:schemeClr val="accent1"/>
+                </a:solidFill>
+              </a:rPr>
+              <a:t>An API request usually includes:</a:t>
+            </a:r>
+          </a:p>
+          <a:p>
+            <a:r>
+              <a:rPr lang="en-US" sz="2400" b="1" dirty="0">
+                <a:solidFill>
+                  <a:schemeClr val="accent1"/>
+                </a:solidFill>
+              </a:rPr>
+              <a:t>Endpoint</a:t>
+            </a:r>
+            <a:r>
+              <a:rPr lang="en-US" sz="2400" dirty="0">
+                <a:solidFill>
+                  <a:schemeClr val="accent1"/>
+                </a:solidFill>
+              </a:rPr>
+              <a:t>: where the request goes</a:t>
+            </a:r>
+          </a:p>
+          <a:p>
+            <a:r>
+              <a:rPr lang="en-US" sz="2400" b="1" dirty="0">
+                <a:solidFill>
+                  <a:schemeClr val="accent1"/>
+                </a:solidFill>
+              </a:rPr>
+              <a:t>Method</a:t>
+            </a:r>
+            <a:r>
+              <a:rPr lang="en-US" sz="2400" dirty="0">
+                <a:solidFill>
+                  <a:schemeClr val="accent1"/>
+                </a:solidFill>
+              </a:rPr>
+              <a:t>: what kind of request, e.g. GET or POST</a:t>
+            </a:r>
+          </a:p>
+          <a:p>
+            <a:r>
+              <a:rPr lang="en-US" sz="2400" b="1" dirty="0">
+                <a:solidFill>
+                  <a:schemeClr val="accent1"/>
+                </a:solidFill>
+              </a:rPr>
+              <a:t>Parameters</a:t>
+            </a:r>
+            <a:r>
+              <a:rPr lang="en-US" sz="2400" dirty="0">
+                <a:solidFill>
+                  <a:schemeClr val="accent1"/>
+                </a:solidFill>
+              </a:rPr>
+              <a:t>: what we ask for</a:t>
+            </a:r>
+          </a:p>
+          <a:p>
+            <a:r>
+              <a:rPr lang="en-US" sz="2400" b="1" dirty="0">
+                <a:solidFill>
+                  <a:schemeClr val="accent1"/>
+                </a:solidFill>
+              </a:rPr>
+              <a:t>Headers</a:t>
+            </a:r>
+            <a:r>
+              <a:rPr lang="en-US" sz="2400" dirty="0">
+                <a:solidFill>
+                  <a:schemeClr val="accent1"/>
+                </a:solidFill>
+              </a:rPr>
+              <a:t>: metadata about the request</a:t>
+            </a:r>
+          </a:p>
+          <a:p>
+            <a:r>
+              <a:rPr lang="en-US" sz="2400" b="1" dirty="0">
+                <a:solidFill>
+                  <a:schemeClr val="accent1"/>
+                </a:solidFill>
+              </a:rPr>
+              <a:t>Authentication</a:t>
+            </a:r>
+            <a:r>
+              <a:rPr lang="en-US" sz="2400" dirty="0">
+                <a:solidFill>
+                  <a:schemeClr val="accent1"/>
+                </a:solidFill>
+              </a:rPr>
+              <a:t>: key/token if required</a:t>
+            </a:r>
+          </a:p>
+          <a:p>
+            <a:pPr marL="1371600" lvl="3" indent="0">
+              <a:buNone/>
+            </a:pPr>
+            <a:endParaRPr lang="en-US" sz="2400" dirty="0">
+              <a:solidFill>
+                <a:schemeClr val="accent1"/>
+              </a:solidFill>
+            </a:endParaRPr>
+          </a:p>
+        </p:txBody>
+      </p:sp>
+    </p:spTree>
+    <p:extLst>
+      <p:ext uri="{BB962C8B-B14F-4D97-AF65-F5344CB8AC3E}">
+        <p14:creationId xmlns:p14="http://schemas.microsoft.com/office/powerpoint/2010/main" val="611198330"/>
       </p:ext>
     </p:extLst>
   </p:cSld>
@@ -12423,625 +11427,6 @@
     <p:extLst>
       <p:ext uri="{BB962C8B-B14F-4D97-AF65-F5344CB8AC3E}">
         <p14:creationId xmlns:p14="http://schemas.microsoft.com/office/powerpoint/2010/main" val="1493801983"/>
-      </p:ext>
-    </p:extLst>
-  </p:cSld>
-  <p:clrMapOvr>
-    <a:masterClrMapping/>
-  </p:clrMapOvr>
-</p:sld>
-</file>
-
-<file path=ppt/slides/slide30.xml><?xml version="1.0" encoding="utf-8"?>
-<p:sld xmlns:a="http://schemas.openxmlformats.org/drawingml/2006/main" xmlns:r="http://schemas.openxmlformats.org/officeDocument/2006/relationships" xmlns:p="http://schemas.openxmlformats.org/presentationml/2006/main">
-  <p:cSld>
-    <p:spTree>
-      <p:nvGrpSpPr>
-        <p:cNvPr id="1" name="">
-          <a:extLst>
-            <a:ext uri="{FF2B5EF4-FFF2-40B4-BE49-F238E27FC236}">
-              <a16:creationId xmlns:a16="http://schemas.microsoft.com/office/drawing/2014/main" id="{A58260FE-ECFF-0268-05BA-97F7BA8F571F}"/>
-            </a:ext>
-          </a:extLst>
-        </p:cNvPr>
-        <p:cNvGrpSpPr/>
-        <p:nvPr/>
-      </p:nvGrpSpPr>
-      <p:grpSpPr>
-        <a:xfrm>
-          <a:off x="0" y="0"/>
-          <a:ext cx="0" cy="0"/>
-          <a:chOff x="0" y="0"/>
-          <a:chExt cx="0" cy="0"/>
-        </a:xfrm>
-      </p:grpSpPr>
-      <p:sp>
-        <p:nvSpPr>
-          <p:cNvPr id="2" name="Title 1">
-            <a:extLst>
-              <a:ext uri="{FF2B5EF4-FFF2-40B4-BE49-F238E27FC236}">
-                <a16:creationId xmlns:a16="http://schemas.microsoft.com/office/drawing/2014/main" id="{F26F5233-FD9F-505B-FDDB-8ED2028034D1}"/>
-              </a:ext>
-            </a:extLst>
-          </p:cNvPr>
-          <p:cNvSpPr>
-            <a:spLocks noGrp="1"/>
-          </p:cNvSpPr>
-          <p:nvPr>
-            <p:ph type="title"/>
-          </p:nvPr>
-        </p:nvSpPr>
-        <p:spPr/>
-        <p:txBody>
-          <a:bodyPr/>
-          <a:lstStyle/>
-          <a:p>
-            <a:r>
-              <a:rPr lang="en-US" dirty="0">
-                <a:solidFill>
-                  <a:schemeClr val="accent1"/>
-                </a:solidFill>
-              </a:rPr>
-              <a:t>How APIs Work</a:t>
-            </a:r>
-          </a:p>
-        </p:txBody>
-      </p:sp>
-      <p:sp>
-        <p:nvSpPr>
-          <p:cNvPr id="3" name="Content Placeholder 2">
-            <a:extLst>
-              <a:ext uri="{FF2B5EF4-FFF2-40B4-BE49-F238E27FC236}">
-                <a16:creationId xmlns:a16="http://schemas.microsoft.com/office/drawing/2014/main" id="{1253A800-82C6-501F-EC81-0E4693AF784C}"/>
-              </a:ext>
-            </a:extLst>
-          </p:cNvPr>
-          <p:cNvSpPr>
-            <a:spLocks noGrp="1"/>
-          </p:cNvSpPr>
-          <p:nvPr>
-            <p:ph idx="1"/>
-          </p:nvPr>
-        </p:nvSpPr>
-        <p:spPr>
-          <a:xfrm>
-            <a:off x="838200" y="1720525"/>
-            <a:ext cx="10515600" cy="4351338"/>
-          </a:xfrm>
-        </p:spPr>
-        <p:txBody>
-          <a:bodyPr/>
-          <a:lstStyle/>
-          <a:p>
-            <a:pPr marL="0" indent="0">
-              <a:buNone/>
-            </a:pPr>
-            <a:r>
-              <a:rPr lang="en-US" sz="2400" dirty="0">
-                <a:solidFill>
-                  <a:schemeClr val="accent1"/>
-                </a:solidFill>
-              </a:rPr>
-              <a:t>APIs operate through a request response cycle between a client and a server</a:t>
-            </a:r>
-          </a:p>
-          <a:p>
-            <a:pPr marL="0" indent="0">
-              <a:buNone/>
-            </a:pPr>
-            <a:endParaRPr lang="en-US" sz="2400" dirty="0">
-              <a:solidFill>
-                <a:schemeClr val="accent1"/>
-              </a:solidFill>
-            </a:endParaRPr>
-          </a:p>
-          <a:p>
-            <a:r>
-              <a:rPr lang="en-US" sz="2400" b="1" dirty="0">
-                <a:solidFill>
-                  <a:schemeClr val="accent1"/>
-                </a:solidFill>
-              </a:rPr>
-              <a:t>Request</a:t>
-            </a:r>
-            <a:r>
-              <a:rPr lang="en-US" sz="2400" dirty="0">
-                <a:solidFill>
-                  <a:schemeClr val="accent1"/>
-                </a:solidFill>
-              </a:rPr>
-              <a:t>: The client sends a request to an API endpoint (URI).</a:t>
-            </a:r>
-          </a:p>
-          <a:p>
-            <a:r>
-              <a:rPr lang="en-US" sz="2400" b="1" dirty="0">
-                <a:solidFill>
-                  <a:schemeClr val="accent1"/>
-                </a:solidFill>
-              </a:rPr>
-              <a:t>Processing</a:t>
-            </a:r>
-            <a:r>
-              <a:rPr lang="en-US" sz="2400" dirty="0">
-                <a:solidFill>
-                  <a:schemeClr val="accent1"/>
-                </a:solidFill>
-              </a:rPr>
-              <a:t>: The API forwards the request to the server.</a:t>
-            </a:r>
-          </a:p>
-          <a:p>
-            <a:r>
-              <a:rPr lang="en-US" sz="2400" b="1" dirty="0">
-                <a:solidFill>
-                  <a:schemeClr val="accent1"/>
-                </a:solidFill>
-              </a:rPr>
-              <a:t>Response</a:t>
-            </a:r>
-            <a:r>
-              <a:rPr lang="en-US" sz="2400" dirty="0">
-                <a:solidFill>
-                  <a:schemeClr val="accent1"/>
-                </a:solidFill>
-              </a:rPr>
-              <a:t>: The server processes and sends back the requested data.</a:t>
-            </a:r>
-          </a:p>
-          <a:p>
-            <a:r>
-              <a:rPr lang="en-US" sz="2400" b="1" dirty="0">
-                <a:solidFill>
-                  <a:schemeClr val="accent1"/>
-                </a:solidFill>
-              </a:rPr>
-              <a:t>Delivery</a:t>
-            </a:r>
-            <a:r>
-              <a:rPr lang="en-US" sz="2400" dirty="0">
-                <a:solidFill>
-                  <a:schemeClr val="accent1"/>
-                </a:solidFill>
-              </a:rPr>
-              <a:t>: The API returns the server’s response to the client.</a:t>
-            </a:r>
-          </a:p>
-          <a:p>
-            <a:pPr marL="0" indent="0">
-              <a:buNone/>
-            </a:pPr>
-            <a:endParaRPr lang="en-US" sz="2400" dirty="0">
-              <a:solidFill>
-                <a:schemeClr val="accent1"/>
-              </a:solidFill>
-            </a:endParaRPr>
-          </a:p>
-          <a:p>
-            <a:pPr marL="0" indent="0">
-              <a:buNone/>
-            </a:pPr>
-            <a:endParaRPr lang="en-US" sz="2400" dirty="0">
-              <a:solidFill>
-                <a:schemeClr val="accent1"/>
-              </a:solidFill>
-            </a:endParaRPr>
-          </a:p>
-        </p:txBody>
-      </p:sp>
-    </p:spTree>
-    <p:extLst>
-      <p:ext uri="{BB962C8B-B14F-4D97-AF65-F5344CB8AC3E}">
-        <p14:creationId xmlns:p14="http://schemas.microsoft.com/office/powerpoint/2010/main" val="490620624"/>
-      </p:ext>
-    </p:extLst>
-  </p:cSld>
-  <p:clrMapOvr>
-    <a:masterClrMapping/>
-  </p:clrMapOvr>
-</p:sld>
-</file>
-
-<file path=ppt/slides/slide31.xml><?xml version="1.0" encoding="utf-8"?>
-<p:sld xmlns:a="http://schemas.openxmlformats.org/drawingml/2006/main" xmlns:r="http://schemas.openxmlformats.org/officeDocument/2006/relationships" xmlns:p="http://schemas.openxmlformats.org/presentationml/2006/main">
-  <p:cSld>
-    <p:spTree>
-      <p:nvGrpSpPr>
-        <p:cNvPr id="1" name="">
-          <a:extLst>
-            <a:ext uri="{FF2B5EF4-FFF2-40B4-BE49-F238E27FC236}">
-              <a16:creationId xmlns:a16="http://schemas.microsoft.com/office/drawing/2014/main" id="{041C1123-DECD-4079-C438-2430965C355C}"/>
-            </a:ext>
-          </a:extLst>
-        </p:cNvPr>
-        <p:cNvGrpSpPr/>
-        <p:nvPr/>
-      </p:nvGrpSpPr>
-      <p:grpSpPr>
-        <a:xfrm>
-          <a:off x="0" y="0"/>
-          <a:ext cx="0" cy="0"/>
-          <a:chOff x="0" y="0"/>
-          <a:chExt cx="0" cy="0"/>
-        </a:xfrm>
-      </p:grpSpPr>
-      <p:sp>
-        <p:nvSpPr>
-          <p:cNvPr id="2" name="Title 1">
-            <a:extLst>
-              <a:ext uri="{FF2B5EF4-FFF2-40B4-BE49-F238E27FC236}">
-                <a16:creationId xmlns:a16="http://schemas.microsoft.com/office/drawing/2014/main" id="{A28EBC7E-8309-FCF2-B52B-F2D348C66A07}"/>
-              </a:ext>
-            </a:extLst>
-          </p:cNvPr>
-          <p:cNvSpPr>
-            <a:spLocks noGrp="1"/>
-          </p:cNvSpPr>
-          <p:nvPr>
-            <p:ph type="title"/>
-          </p:nvPr>
-        </p:nvSpPr>
-        <p:spPr/>
-        <p:txBody>
-          <a:bodyPr/>
-          <a:lstStyle/>
-          <a:p>
-            <a:r>
-              <a:rPr lang="en-US" dirty="0">
-                <a:solidFill>
-                  <a:schemeClr val="accent1"/>
-                </a:solidFill>
-              </a:rPr>
-              <a:t>Anatomy of an API request</a:t>
-            </a:r>
-          </a:p>
-        </p:txBody>
-      </p:sp>
-      <p:sp>
-        <p:nvSpPr>
-          <p:cNvPr id="3" name="Content Placeholder 2">
-            <a:extLst>
-              <a:ext uri="{FF2B5EF4-FFF2-40B4-BE49-F238E27FC236}">
-                <a16:creationId xmlns:a16="http://schemas.microsoft.com/office/drawing/2014/main" id="{300F8743-820D-4C7B-CC96-CEFB7B708F76}"/>
-              </a:ext>
-            </a:extLst>
-          </p:cNvPr>
-          <p:cNvSpPr>
-            <a:spLocks noGrp="1"/>
-          </p:cNvSpPr>
-          <p:nvPr>
-            <p:ph idx="1"/>
-          </p:nvPr>
-        </p:nvSpPr>
-        <p:spPr>
-          <a:xfrm>
-            <a:off x="838200" y="1720525"/>
-            <a:ext cx="10515600" cy="4351338"/>
-          </a:xfrm>
-        </p:spPr>
-        <p:txBody>
-          <a:bodyPr/>
-          <a:lstStyle/>
-          <a:p>
-            <a:pPr marL="0" indent="0">
-              <a:buNone/>
-            </a:pPr>
-            <a:r>
-              <a:rPr lang="en-US" dirty="0">
-                <a:solidFill>
-                  <a:schemeClr val="accent1"/>
-                </a:solidFill>
-              </a:rPr>
-              <a:t>An API request usually includes:</a:t>
-            </a:r>
-          </a:p>
-          <a:p>
-            <a:r>
-              <a:rPr lang="en-US" sz="2400" b="1" dirty="0">
-                <a:solidFill>
-                  <a:schemeClr val="accent1"/>
-                </a:solidFill>
-              </a:rPr>
-              <a:t>Endpoint</a:t>
-            </a:r>
-            <a:r>
-              <a:rPr lang="en-US" sz="2400" dirty="0">
-                <a:solidFill>
-                  <a:schemeClr val="accent1"/>
-                </a:solidFill>
-              </a:rPr>
-              <a:t>: where the request goes</a:t>
-            </a:r>
-          </a:p>
-          <a:p>
-            <a:r>
-              <a:rPr lang="en-US" sz="2400" b="1" dirty="0">
-                <a:solidFill>
-                  <a:schemeClr val="accent1"/>
-                </a:solidFill>
-              </a:rPr>
-              <a:t>Method</a:t>
-            </a:r>
-            <a:r>
-              <a:rPr lang="en-US" sz="2400" dirty="0">
-                <a:solidFill>
-                  <a:schemeClr val="accent1"/>
-                </a:solidFill>
-              </a:rPr>
-              <a:t>: what kind of request, e.g. GET or POST</a:t>
-            </a:r>
-          </a:p>
-          <a:p>
-            <a:r>
-              <a:rPr lang="en-US" sz="2400" b="1" dirty="0">
-                <a:solidFill>
-                  <a:schemeClr val="accent1"/>
-                </a:solidFill>
-              </a:rPr>
-              <a:t>Parameters</a:t>
-            </a:r>
-            <a:r>
-              <a:rPr lang="en-US" sz="2400" dirty="0">
-                <a:solidFill>
-                  <a:schemeClr val="accent1"/>
-                </a:solidFill>
-              </a:rPr>
-              <a:t>: what we ask for</a:t>
-            </a:r>
-          </a:p>
-          <a:p>
-            <a:r>
-              <a:rPr lang="en-US" sz="2400" b="1" dirty="0">
-                <a:solidFill>
-                  <a:schemeClr val="accent1"/>
-                </a:solidFill>
-              </a:rPr>
-              <a:t>Headers</a:t>
-            </a:r>
-            <a:r>
-              <a:rPr lang="en-US" sz="2400" dirty="0">
-                <a:solidFill>
-                  <a:schemeClr val="accent1"/>
-                </a:solidFill>
-              </a:rPr>
-              <a:t>: metadata about the request</a:t>
-            </a:r>
-          </a:p>
-          <a:p>
-            <a:r>
-              <a:rPr lang="en-US" sz="2400" b="1" dirty="0">
-                <a:solidFill>
-                  <a:schemeClr val="accent1"/>
-                </a:solidFill>
-              </a:rPr>
-              <a:t>Authentication</a:t>
-            </a:r>
-            <a:r>
-              <a:rPr lang="en-US" sz="2400" dirty="0">
-                <a:solidFill>
-                  <a:schemeClr val="accent1"/>
-                </a:solidFill>
-              </a:rPr>
-              <a:t>: key/token if required</a:t>
-            </a:r>
-          </a:p>
-          <a:p>
-            <a:pPr marL="1371600" lvl="3" indent="0">
-              <a:buNone/>
-            </a:pPr>
-            <a:endParaRPr lang="en-US" sz="2400" dirty="0">
-              <a:solidFill>
-                <a:schemeClr val="accent1"/>
-              </a:solidFill>
-            </a:endParaRPr>
-          </a:p>
-        </p:txBody>
-      </p:sp>
-    </p:spTree>
-    <p:extLst>
-      <p:ext uri="{BB962C8B-B14F-4D97-AF65-F5344CB8AC3E}">
-        <p14:creationId xmlns:p14="http://schemas.microsoft.com/office/powerpoint/2010/main" val="611198330"/>
-      </p:ext>
-    </p:extLst>
-  </p:cSld>
-  <p:clrMapOvr>
-    <a:masterClrMapping/>
-  </p:clrMapOvr>
-</p:sld>
-</file>
-
-<file path=ppt/slides/slide32.xml><?xml version="1.0" encoding="utf-8"?>
-<p:sld xmlns:a="http://schemas.openxmlformats.org/drawingml/2006/main" xmlns:r="http://schemas.openxmlformats.org/officeDocument/2006/relationships" xmlns:p="http://schemas.openxmlformats.org/presentationml/2006/main">
-  <p:cSld>
-    <p:spTree>
-      <p:nvGrpSpPr>
-        <p:cNvPr id="1" name=""/>
-        <p:cNvGrpSpPr/>
-        <p:nvPr/>
-      </p:nvGrpSpPr>
-      <p:grpSpPr>
-        <a:xfrm>
-          <a:off x="0" y="0"/>
-          <a:ext cx="0" cy="0"/>
-          <a:chOff x="0" y="0"/>
-          <a:chExt cx="0" cy="0"/>
-        </a:xfrm>
-      </p:grpSpPr>
-      <p:sp>
-        <p:nvSpPr>
-          <p:cNvPr id="2" name="Title 1">
-            <a:extLst>
-              <a:ext uri="{FF2B5EF4-FFF2-40B4-BE49-F238E27FC236}">
-                <a16:creationId xmlns:a16="http://schemas.microsoft.com/office/drawing/2014/main" id="{C01E33A6-E9E2-5A75-86DD-2970D71281C1}"/>
-              </a:ext>
-            </a:extLst>
-          </p:cNvPr>
-          <p:cNvSpPr>
-            <a:spLocks noGrp="1"/>
-          </p:cNvSpPr>
-          <p:nvPr>
-            <p:ph type="title"/>
-          </p:nvPr>
-        </p:nvSpPr>
-        <p:spPr/>
-        <p:txBody>
-          <a:bodyPr/>
-          <a:lstStyle/>
-          <a:p>
-            <a:r>
-              <a:rPr lang="en-US" dirty="0">
-                <a:solidFill>
-                  <a:schemeClr val="accent1"/>
-                </a:solidFill>
-              </a:rPr>
-              <a:t>Agenda for the rest of the day…</a:t>
-            </a:r>
-          </a:p>
-        </p:txBody>
-      </p:sp>
-      <p:sp>
-        <p:nvSpPr>
-          <p:cNvPr id="3" name="Content Placeholder 2">
-            <a:extLst>
-              <a:ext uri="{FF2B5EF4-FFF2-40B4-BE49-F238E27FC236}">
-                <a16:creationId xmlns:a16="http://schemas.microsoft.com/office/drawing/2014/main" id="{91A11D33-6003-721D-CCD9-E1EAA6C583BA}"/>
-              </a:ext>
-            </a:extLst>
-          </p:cNvPr>
-          <p:cNvSpPr>
-            <a:spLocks noGrp="1"/>
-          </p:cNvSpPr>
-          <p:nvPr>
-            <p:ph idx="1"/>
-          </p:nvPr>
-        </p:nvSpPr>
-        <p:spPr>
-          <a:xfrm>
-            <a:off x="838200" y="1720525"/>
-            <a:ext cx="10515600" cy="4351338"/>
-          </a:xfrm>
-        </p:spPr>
-        <p:txBody>
-          <a:bodyPr>
-            <a:normAutofit/>
-          </a:bodyPr>
-          <a:lstStyle/>
-          <a:p>
-            <a:pPr marL="0" indent="0">
-              <a:buNone/>
-            </a:pPr>
-            <a:endParaRPr lang="en-US" dirty="0">
-              <a:solidFill>
-                <a:schemeClr val="accent1"/>
-              </a:solidFill>
-            </a:endParaRPr>
-          </a:p>
-          <a:p>
-            <a:pPr lvl="1"/>
-            <a:r>
-              <a:rPr lang="en-US" sz="2800" dirty="0">
-                <a:solidFill>
-                  <a:schemeClr val="accent1"/>
-                </a:solidFill>
-              </a:rPr>
-              <a:t>send an API request (we use the </a:t>
-            </a:r>
-            <a:r>
-              <a:rPr lang="en-US" sz="2800" b="1" dirty="0" err="1">
-                <a:solidFill>
-                  <a:schemeClr val="accent1"/>
-                </a:solidFill>
-              </a:rPr>
-              <a:t>MediaWiki</a:t>
-            </a:r>
-            <a:r>
-              <a:rPr lang="en-US" sz="2800" b="1" dirty="0">
-                <a:solidFill>
-                  <a:schemeClr val="accent1"/>
-                </a:solidFill>
-              </a:rPr>
-              <a:t> API </a:t>
-            </a:r>
-            <a:r>
-              <a:rPr lang="en-US" sz="2800" dirty="0">
-                <a:solidFill>
-                  <a:schemeClr val="accent1"/>
-                </a:solidFill>
-              </a:rPr>
-              <a:t>as example)</a:t>
-            </a:r>
-          </a:p>
-          <a:p>
-            <a:pPr lvl="1"/>
-            <a:r>
-              <a:rPr lang="en-US" sz="2800" dirty="0">
-                <a:solidFill>
-                  <a:schemeClr val="accent1"/>
-                </a:solidFill>
-              </a:rPr>
-              <a:t>inspect the response</a:t>
-            </a:r>
-          </a:p>
-          <a:p>
-            <a:pPr lvl="1"/>
-            <a:r>
-              <a:rPr lang="en-US" sz="2800" dirty="0">
-                <a:solidFill>
-                  <a:schemeClr val="accent1"/>
-                </a:solidFill>
-              </a:rPr>
-              <a:t>understand JSON</a:t>
-            </a:r>
-          </a:p>
-          <a:p>
-            <a:pPr lvl="1"/>
-            <a:r>
-              <a:rPr lang="en-US" sz="2800" dirty="0">
-                <a:solidFill>
-                  <a:schemeClr val="accent1"/>
-                </a:solidFill>
-              </a:rPr>
-              <a:t>turn search results into a table</a:t>
-            </a:r>
-          </a:p>
-          <a:p>
-            <a:pPr lvl="1"/>
-            <a:r>
-              <a:rPr lang="en-US" sz="2800" dirty="0">
-                <a:solidFill>
-                  <a:schemeClr val="accent1"/>
-                </a:solidFill>
-              </a:rPr>
-              <a:t>follow pagination</a:t>
-            </a:r>
-          </a:p>
-          <a:p>
-            <a:pPr lvl="1"/>
-            <a:r>
-              <a:rPr lang="en-US" sz="2800" dirty="0">
-                <a:solidFill>
-                  <a:schemeClr val="accent1"/>
-                </a:solidFill>
-              </a:rPr>
-              <a:t>retrieve page-level data</a:t>
-            </a:r>
-          </a:p>
-          <a:p>
-            <a:pPr marL="0" indent="0">
-              <a:buNone/>
-            </a:pPr>
-            <a:endParaRPr lang="en-US" dirty="0">
-              <a:solidFill>
-                <a:schemeClr val="accent1"/>
-              </a:solidFill>
-            </a:endParaRPr>
-          </a:p>
-        </p:txBody>
-      </p:sp>
-    </p:spTree>
-    <p:extLst>
-      <p:ext uri="{BB962C8B-B14F-4D97-AF65-F5344CB8AC3E}">
-        <p14:creationId xmlns:p14="http://schemas.microsoft.com/office/powerpoint/2010/main" val="1727965126"/>
       </p:ext>
     </p:extLst>
   </p:cSld>

</xml_diff>